<commit_message>
Update Classificação Incremental e Auditável de Crimes em Notícias.pptx
</commit_message>
<xml_diff>
--- a/output/Classificação Incremental e Auditável de Crimes em Notícias.pptx
+++ b/output/Classificação Incremental e Auditável de Crimes em Notícias.pptx
@@ -24,7 +24,8 @@
     <p:sldId id="272" r:id="rId18"/>
     <p:sldId id="273" r:id="rId19"/>
     <p:sldId id="274" r:id="rId20"/>
-    <p:sldId id="275" r:id="rId21"/>
+    <p:sldId id="276" r:id="rId21"/>
+    <p:sldId id="275" r:id="rId22"/>
   </p:sldIdLst>
   <p:sldSz cx="12192000" cy="6858000"/>
   <p:notesSz cx="6858000" cy="9144000"/>
@@ -181,7 +182,7 @@
           <a:noFill/>
           <a:extLst>
             <a:ext uri="{909E8E84-426E-40dd-AFC4-6F175D3DCCD1}">
-              <a14:hiddenFill xmlns="" xmlns:a14="http://schemas.microsoft.com/office/drawing/2010/main">
+              <a14:hiddenFill xmlns:a14="http://schemas.microsoft.com/office/drawing/2010/main" xmlns="">
                 <a:solidFill>
                   <a:srgbClr val="FFFFFF"/>
                 </a:solidFill>
@@ -241,7 +242,7 @@
             </a:ln>
             <a:extLst>
               <a:ext uri="{91240B29-F687-4f45-9708-019B960494DF}">
-                <a14:hiddenLine xmlns="" xmlns:a14="http://schemas.microsoft.com/office/drawing/2010/main" w="9525">
+                <a14:hiddenLine xmlns:a14="http://schemas.microsoft.com/office/drawing/2010/main" xmlns="" w="9525">
                   <a:solidFill>
                     <a:srgbClr val="000000"/>
                   </a:solidFill>
@@ -338,7 +339,7 @@
             </a:ln>
             <a:extLst>
               <a:ext uri="{91240B29-F687-4f45-9708-019B960494DF}">
-                <a14:hiddenLine xmlns="" xmlns:a14="http://schemas.microsoft.com/office/drawing/2010/main" w="9525">
+                <a14:hiddenLine xmlns:a14="http://schemas.microsoft.com/office/drawing/2010/main" xmlns="" w="9525">
                   <a:solidFill>
                     <a:srgbClr val="000000"/>
                   </a:solidFill>
@@ -435,7 +436,7 @@
             </a:ln>
             <a:extLst>
               <a:ext uri="{91240B29-F687-4f45-9708-019B960494DF}">
-                <a14:hiddenLine xmlns="" xmlns:a14="http://schemas.microsoft.com/office/drawing/2010/main" w="9525">
+                <a14:hiddenLine xmlns:a14="http://schemas.microsoft.com/office/drawing/2010/main" xmlns="" w="9525">
                   <a:solidFill>
                     <a:srgbClr val="000000"/>
                   </a:solidFill>
@@ -476,7 +477,7 @@
             </a:ln>
             <a:extLst>
               <a:ext uri="{91240B29-F687-4f45-9708-019B960494DF}">
-                <a14:hiddenLine xmlns="" xmlns:a14="http://schemas.microsoft.com/office/drawing/2010/main" w="9525">
+                <a14:hiddenLine xmlns:a14="http://schemas.microsoft.com/office/drawing/2010/main" xmlns="" w="9525">
                   <a:solidFill>
                     <a:srgbClr val="000000"/>
                   </a:solidFill>
@@ -573,7 +574,7 @@
             </a:ln>
             <a:extLst>
               <a:ext uri="{91240B29-F687-4f45-9708-019B960494DF}">
-                <a14:hiddenLine xmlns="" xmlns:a14="http://schemas.microsoft.com/office/drawing/2010/main" w="9525">
+                <a14:hiddenLine xmlns:a14="http://schemas.microsoft.com/office/drawing/2010/main" xmlns="" w="9525">
                   <a:solidFill>
                     <a:srgbClr val="000000"/>
                   </a:solidFill>
@@ -642,7 +643,7 @@
             </a:ln>
             <a:extLst>
               <a:ext uri="{91240B29-F687-4f45-9708-019B960494DF}">
-                <a14:hiddenLine xmlns="" xmlns:a14="http://schemas.microsoft.com/office/drawing/2010/main" w="9525">
+                <a14:hiddenLine xmlns:a14="http://schemas.microsoft.com/office/drawing/2010/main" xmlns="" w="9525">
                   <a:solidFill>
                     <a:srgbClr val="000000"/>
                   </a:solidFill>
@@ -711,7 +712,7 @@
             </a:ln>
             <a:extLst>
               <a:ext uri="{91240B29-F687-4f45-9708-019B960494DF}">
-                <a14:hiddenLine xmlns="" xmlns:a14="http://schemas.microsoft.com/office/drawing/2010/main" w="9525">
+                <a14:hiddenLine xmlns:a14="http://schemas.microsoft.com/office/drawing/2010/main" xmlns="" w="9525">
                   <a:solidFill>
                     <a:srgbClr val="000000"/>
                   </a:solidFill>
@@ -808,7 +809,7 @@
             </a:ln>
             <a:extLst>
               <a:ext uri="{91240B29-F687-4f45-9708-019B960494DF}">
-                <a14:hiddenLine xmlns="" xmlns:a14="http://schemas.microsoft.com/office/drawing/2010/main" w="9525">
+                <a14:hiddenLine xmlns:a14="http://schemas.microsoft.com/office/drawing/2010/main" xmlns="" w="9525">
                   <a:solidFill>
                     <a:srgbClr val="000000"/>
                   </a:solidFill>
@@ -877,7 +878,7 @@
             </a:ln>
             <a:extLst>
               <a:ext uri="{91240B29-F687-4f45-9708-019B960494DF}">
-                <a14:hiddenLine xmlns="" xmlns:a14="http://schemas.microsoft.com/office/drawing/2010/main" w="9525">
+                <a14:hiddenLine xmlns:a14="http://schemas.microsoft.com/office/drawing/2010/main" xmlns="" w="9525">
                   <a:solidFill>
                     <a:srgbClr val="000000"/>
                   </a:solidFill>
@@ -946,7 +947,7 @@
             </a:ln>
             <a:extLst>
               <a:ext uri="{91240B29-F687-4f45-9708-019B960494DF}">
-                <a14:hiddenLine xmlns="" xmlns:a14="http://schemas.microsoft.com/office/drawing/2010/main" w="9525">
+                <a14:hiddenLine xmlns:a14="http://schemas.microsoft.com/office/drawing/2010/main" xmlns="" w="9525">
                   <a:solidFill>
                     <a:srgbClr val="000000"/>
                   </a:solidFill>
@@ -1043,7 +1044,7 @@
             </a:ln>
             <a:extLst>
               <a:ext uri="{91240B29-F687-4f45-9708-019B960494DF}">
-                <a14:hiddenLine xmlns="" xmlns:a14="http://schemas.microsoft.com/office/drawing/2010/main" w="9525">
+                <a14:hiddenLine xmlns:a14="http://schemas.microsoft.com/office/drawing/2010/main" xmlns="" w="9525">
                   <a:solidFill>
                     <a:srgbClr val="000000"/>
                   </a:solidFill>
@@ -1140,7 +1141,7 @@
             </a:ln>
             <a:extLst>
               <a:ext uri="{91240B29-F687-4f45-9708-019B960494DF}">
-                <a14:hiddenLine xmlns="" xmlns:a14="http://schemas.microsoft.com/office/drawing/2010/main" w="9525">
+                <a14:hiddenLine xmlns:a14="http://schemas.microsoft.com/office/drawing/2010/main" xmlns="" w="9525">
                   <a:solidFill>
                     <a:srgbClr val="000000"/>
                   </a:solidFill>
@@ -1209,7 +1210,7 @@
             </a:ln>
             <a:extLst>
               <a:ext uri="{91240B29-F687-4f45-9708-019B960494DF}">
-                <a14:hiddenLine xmlns="" xmlns:a14="http://schemas.microsoft.com/office/drawing/2010/main" w="9525">
+                <a14:hiddenLine xmlns:a14="http://schemas.microsoft.com/office/drawing/2010/main" xmlns="" w="9525">
                   <a:solidFill>
                     <a:srgbClr val="000000"/>
                   </a:solidFill>
@@ -1326,7 +1327,7 @@
             </a:ln>
             <a:extLst>
               <a:ext uri="{91240B29-F687-4f45-9708-019B960494DF}">
-                <a14:hiddenLine xmlns="" xmlns:a14="http://schemas.microsoft.com/office/drawing/2010/main" w="9525">
+                <a14:hiddenLine xmlns:a14="http://schemas.microsoft.com/office/drawing/2010/main" xmlns="" w="9525">
                   <a:solidFill>
                     <a:srgbClr val="000000"/>
                   </a:solidFill>
@@ -1395,7 +1396,7 @@
             </a:ln>
             <a:extLst>
               <a:ext uri="{91240B29-F687-4f45-9708-019B960494DF}">
-                <a14:hiddenLine xmlns="" xmlns:a14="http://schemas.microsoft.com/office/drawing/2010/main" w="9525">
+                <a14:hiddenLine xmlns:a14="http://schemas.microsoft.com/office/drawing/2010/main" xmlns="" w="9525">
                   <a:solidFill>
                     <a:srgbClr val="000000"/>
                   </a:solidFill>
@@ -1492,7 +1493,7 @@
             </a:ln>
             <a:extLst>
               <a:ext uri="{91240B29-F687-4f45-9708-019B960494DF}">
-                <a14:hiddenLine xmlns="" xmlns:a14="http://schemas.microsoft.com/office/drawing/2010/main" w="9525">
+                <a14:hiddenLine xmlns:a14="http://schemas.microsoft.com/office/drawing/2010/main" xmlns="" w="9525">
                   <a:solidFill>
                     <a:srgbClr val="000000"/>
                   </a:solidFill>
@@ -1589,7 +1590,7 @@
             </a:ln>
             <a:extLst>
               <a:ext uri="{91240B29-F687-4f45-9708-019B960494DF}">
-                <a14:hiddenLine xmlns="" xmlns:a14="http://schemas.microsoft.com/office/drawing/2010/main" w="9525">
+                <a14:hiddenLine xmlns:a14="http://schemas.microsoft.com/office/drawing/2010/main" xmlns="" w="9525">
                   <a:solidFill>
                     <a:srgbClr val="000000"/>
                   </a:solidFill>
@@ -1658,7 +1659,7 @@
             </a:ln>
             <a:extLst>
               <a:ext uri="{91240B29-F687-4f45-9708-019B960494DF}">
-                <a14:hiddenLine xmlns="" xmlns:a14="http://schemas.microsoft.com/office/drawing/2010/main" w="9525">
+                <a14:hiddenLine xmlns:a14="http://schemas.microsoft.com/office/drawing/2010/main" xmlns="" w="9525">
                   <a:solidFill>
                     <a:srgbClr val="000000"/>
                   </a:solidFill>
@@ -1755,7 +1756,7 @@
             </a:ln>
             <a:extLst>
               <a:ext uri="{91240B29-F687-4f45-9708-019B960494DF}">
-                <a14:hiddenLine xmlns="" xmlns:a14="http://schemas.microsoft.com/office/drawing/2010/main" w="9525">
+                <a14:hiddenLine xmlns:a14="http://schemas.microsoft.com/office/drawing/2010/main" xmlns="" w="9525">
                   <a:solidFill>
                     <a:srgbClr val="000000"/>
                   </a:solidFill>
@@ -1852,7 +1853,7 @@
             </a:ln>
             <a:extLst>
               <a:ext uri="{91240B29-F687-4f45-9708-019B960494DF}">
-                <a14:hiddenLine xmlns="" xmlns:a14="http://schemas.microsoft.com/office/drawing/2010/main" w="9525">
+                <a14:hiddenLine xmlns:a14="http://schemas.microsoft.com/office/drawing/2010/main" xmlns="" w="9525">
                   <a:solidFill>
                     <a:srgbClr val="000000"/>
                   </a:solidFill>
@@ -1915,7 +1916,7 @@
             </a:ln>
             <a:extLst>
               <a:ext uri="{91240B29-F687-4f45-9708-019B960494DF}">
-                <a14:hiddenLine xmlns="" xmlns:a14="http://schemas.microsoft.com/office/drawing/2010/main" w="9525">
+                <a14:hiddenLine xmlns:a14="http://schemas.microsoft.com/office/drawing/2010/main" xmlns="" w="9525">
                   <a:solidFill>
                     <a:srgbClr val="000000"/>
                   </a:solidFill>
@@ -2012,7 +2013,7 @@
             </a:ln>
             <a:extLst>
               <a:ext uri="{91240B29-F687-4f45-9708-019B960494DF}">
-                <a14:hiddenLine xmlns="" xmlns:a14="http://schemas.microsoft.com/office/drawing/2010/main" w="9525">
+                <a14:hiddenLine xmlns:a14="http://schemas.microsoft.com/office/drawing/2010/main" xmlns="" w="9525">
                   <a:solidFill>
                     <a:srgbClr val="000000"/>
                   </a:solidFill>
@@ -2075,7 +2076,7 @@
             </a:ln>
             <a:extLst>
               <a:ext uri="{91240B29-F687-4f45-9708-019B960494DF}">
-                <a14:hiddenLine xmlns="" xmlns:a14="http://schemas.microsoft.com/office/drawing/2010/main" w="9525">
+                <a14:hiddenLine xmlns:a14="http://schemas.microsoft.com/office/drawing/2010/main" xmlns="" w="9525">
                   <a:solidFill>
                     <a:srgbClr val="000000"/>
                   </a:solidFill>
@@ -2172,7 +2173,7 @@
             </a:ln>
             <a:extLst>
               <a:ext uri="{91240B29-F687-4f45-9708-019B960494DF}">
-                <a14:hiddenLine xmlns="" xmlns:a14="http://schemas.microsoft.com/office/drawing/2010/main" w="9525">
+                <a14:hiddenLine xmlns:a14="http://schemas.microsoft.com/office/drawing/2010/main" xmlns="" w="9525">
                   <a:solidFill>
                     <a:srgbClr val="000000"/>
                   </a:solidFill>
@@ -2247,7 +2248,7 @@
             </a:ln>
             <a:extLst>
               <a:ext uri="{91240B29-F687-4f45-9708-019B960494DF}">
-                <a14:hiddenLine xmlns="" xmlns:a14="http://schemas.microsoft.com/office/drawing/2010/main" w="9525">
+                <a14:hiddenLine xmlns:a14="http://schemas.microsoft.com/office/drawing/2010/main" xmlns="" w="9525">
                   <a:solidFill>
                     <a:srgbClr val="000000"/>
                   </a:solidFill>
@@ -2344,7 +2345,7 @@
             </a:ln>
             <a:extLst>
               <a:ext uri="{91240B29-F687-4f45-9708-019B960494DF}">
-                <a14:hiddenLine xmlns="" xmlns:a14="http://schemas.microsoft.com/office/drawing/2010/main" w="9525">
+                <a14:hiddenLine xmlns:a14="http://schemas.microsoft.com/office/drawing/2010/main" xmlns="" w="9525">
                   <a:solidFill>
                     <a:srgbClr val="000000"/>
                   </a:solidFill>
@@ -2419,7 +2420,7 @@
             </a:ln>
             <a:extLst>
               <a:ext uri="{91240B29-F687-4f45-9708-019B960494DF}">
-                <a14:hiddenLine xmlns="" xmlns:a14="http://schemas.microsoft.com/office/drawing/2010/main" w="9525">
+                <a14:hiddenLine xmlns:a14="http://schemas.microsoft.com/office/drawing/2010/main" xmlns="" w="9525">
                   <a:solidFill>
                     <a:srgbClr val="000000"/>
                   </a:solidFill>
@@ -2516,7 +2517,7 @@
             </a:ln>
             <a:extLst>
               <a:ext uri="{91240B29-F687-4f45-9708-019B960494DF}">
-                <a14:hiddenLine xmlns="" xmlns:a14="http://schemas.microsoft.com/office/drawing/2010/main" w="9525">
+                <a14:hiddenLine xmlns:a14="http://schemas.microsoft.com/office/drawing/2010/main" xmlns="" w="9525">
                   <a:solidFill>
                     <a:srgbClr val="000000"/>
                   </a:solidFill>
@@ -2557,7 +2558,7 @@
             </a:ln>
             <a:extLst>
               <a:ext uri="{91240B29-F687-4f45-9708-019B960494DF}">
-                <a14:hiddenLine xmlns="" xmlns:a14="http://schemas.microsoft.com/office/drawing/2010/main" w="9525">
+                <a14:hiddenLine xmlns:a14="http://schemas.microsoft.com/office/drawing/2010/main" xmlns="" w="9525">
                   <a:solidFill>
                     <a:srgbClr val="000000"/>
                   </a:solidFill>
@@ -2654,7 +2655,7 @@
             </a:ln>
             <a:extLst>
               <a:ext uri="{91240B29-F687-4f45-9708-019B960494DF}">
-                <a14:hiddenLine xmlns="" xmlns:a14="http://schemas.microsoft.com/office/drawing/2010/main" w="9525">
+                <a14:hiddenLine xmlns:a14="http://schemas.microsoft.com/office/drawing/2010/main" xmlns="" w="9525">
                   <a:solidFill>
                     <a:srgbClr val="000000"/>
                   </a:solidFill>
@@ -2723,7 +2724,7 @@
             </a:ln>
             <a:extLst>
               <a:ext uri="{91240B29-F687-4f45-9708-019B960494DF}">
-                <a14:hiddenLine xmlns="" xmlns:a14="http://schemas.microsoft.com/office/drawing/2010/main" w="9525">
+                <a14:hiddenLine xmlns:a14="http://schemas.microsoft.com/office/drawing/2010/main" xmlns="" w="9525">
                   <a:solidFill>
                     <a:srgbClr val="000000"/>
                   </a:solidFill>
@@ -2792,7 +2793,7 @@
             </a:ln>
             <a:extLst>
               <a:ext uri="{91240B29-F687-4f45-9708-019B960494DF}">
-                <a14:hiddenLine xmlns="" xmlns:a14="http://schemas.microsoft.com/office/drawing/2010/main" w="9525">
+                <a14:hiddenLine xmlns:a14="http://schemas.microsoft.com/office/drawing/2010/main" xmlns="" w="9525">
                   <a:solidFill>
                     <a:srgbClr val="000000"/>
                   </a:solidFill>
@@ -2889,7 +2890,7 @@
             </a:ln>
             <a:extLst>
               <a:ext uri="{91240B29-F687-4f45-9708-019B960494DF}">
-                <a14:hiddenLine xmlns="" xmlns:a14="http://schemas.microsoft.com/office/drawing/2010/main" w="9525">
+                <a14:hiddenLine xmlns:a14="http://schemas.microsoft.com/office/drawing/2010/main" xmlns="" w="9525">
                   <a:solidFill>
                     <a:srgbClr val="000000"/>
                   </a:solidFill>
@@ -2964,7 +2965,7 @@
             </a:ln>
             <a:extLst>
               <a:ext uri="{91240B29-F687-4f45-9708-019B960494DF}">
-                <a14:hiddenLine xmlns="" xmlns:a14="http://schemas.microsoft.com/office/drawing/2010/main" w="9525">
+                <a14:hiddenLine xmlns:a14="http://schemas.microsoft.com/office/drawing/2010/main" xmlns="" w="9525">
                   <a:solidFill>
                     <a:srgbClr val="000000"/>
                   </a:solidFill>
@@ -3033,7 +3034,7 @@
             </a:ln>
             <a:extLst>
               <a:ext uri="{91240B29-F687-4f45-9708-019B960494DF}">
-                <a14:hiddenLine xmlns="" xmlns:a14="http://schemas.microsoft.com/office/drawing/2010/main" w="9525">
+                <a14:hiddenLine xmlns:a14="http://schemas.microsoft.com/office/drawing/2010/main" xmlns="" w="9525">
                   <a:solidFill>
                     <a:srgbClr val="000000"/>
                   </a:solidFill>
@@ -3130,7 +3131,7 @@
             </a:ln>
             <a:extLst>
               <a:ext uri="{91240B29-F687-4f45-9708-019B960494DF}">
-                <a14:hiddenLine xmlns="" xmlns:a14="http://schemas.microsoft.com/office/drawing/2010/main" w="9525">
+                <a14:hiddenLine xmlns:a14="http://schemas.microsoft.com/office/drawing/2010/main" xmlns="" w="9525">
                   <a:solidFill>
                     <a:srgbClr val="000000"/>
                   </a:solidFill>
@@ -3199,7 +3200,7 @@
             </a:ln>
             <a:extLst>
               <a:ext uri="{91240B29-F687-4f45-9708-019B960494DF}">
-                <a14:hiddenLine xmlns="" xmlns:a14="http://schemas.microsoft.com/office/drawing/2010/main" w="9525">
+                <a14:hiddenLine xmlns:a14="http://schemas.microsoft.com/office/drawing/2010/main" xmlns="" w="9525">
                   <a:solidFill>
                     <a:srgbClr val="000000"/>
                   </a:solidFill>
@@ -3296,7 +3297,7 @@
             </a:ln>
             <a:extLst>
               <a:ext uri="{91240B29-F687-4f45-9708-019B960494DF}">
-                <a14:hiddenLine xmlns="" xmlns:a14="http://schemas.microsoft.com/office/drawing/2010/main" w="9525">
+                <a14:hiddenLine xmlns:a14="http://schemas.microsoft.com/office/drawing/2010/main" xmlns="" w="9525">
                   <a:solidFill>
                     <a:srgbClr val="000000"/>
                   </a:solidFill>
@@ -3365,7 +3366,7 @@
             </a:ln>
             <a:extLst>
               <a:ext uri="{91240B29-F687-4f45-9708-019B960494DF}">
-                <a14:hiddenLine xmlns="" xmlns:a14="http://schemas.microsoft.com/office/drawing/2010/main" w="9525">
+                <a14:hiddenLine xmlns:a14="http://schemas.microsoft.com/office/drawing/2010/main" xmlns="" w="9525">
                   <a:solidFill>
                     <a:srgbClr val="000000"/>
                   </a:solidFill>
@@ -3462,7 +3463,7 @@
             </a:ln>
             <a:extLst>
               <a:ext uri="{91240B29-F687-4f45-9708-019B960494DF}">
-                <a14:hiddenLine xmlns="" xmlns:a14="http://schemas.microsoft.com/office/drawing/2010/main" w="9525">
+                <a14:hiddenLine xmlns:a14="http://schemas.microsoft.com/office/drawing/2010/main" xmlns="" w="9525">
                   <a:solidFill>
                     <a:srgbClr val="000000"/>
                   </a:solidFill>
@@ -3503,7 +3504,7 @@
             </a:ln>
             <a:extLst>
               <a:ext uri="{91240B29-F687-4f45-9708-019B960494DF}">
-                <a14:hiddenLine xmlns="" xmlns:a14="http://schemas.microsoft.com/office/drawing/2010/main" w="9525">
+                <a14:hiddenLine xmlns:a14="http://schemas.microsoft.com/office/drawing/2010/main" xmlns="" w="9525">
                   <a:solidFill>
                     <a:srgbClr val="000000"/>
                   </a:solidFill>
@@ -3575,7 +3576,7 @@
             </a:ln>
             <a:extLst>
               <a:ext uri="{91240B29-F687-4f45-9708-019B960494DF}">
-                <a14:hiddenLine xmlns="" xmlns:a14="http://schemas.microsoft.com/office/drawing/2010/main" w="9525">
+                <a14:hiddenLine xmlns:a14="http://schemas.microsoft.com/office/drawing/2010/main" xmlns="" w="9525">
                   <a:solidFill>
                     <a:srgbClr val="000000"/>
                   </a:solidFill>
@@ -3672,7 +3673,7 @@
             </a:ln>
             <a:extLst>
               <a:ext uri="{91240B29-F687-4f45-9708-019B960494DF}">
-                <a14:hiddenLine xmlns="" xmlns:a14="http://schemas.microsoft.com/office/drawing/2010/main" w="9525">
+                <a14:hiddenLine xmlns:a14="http://schemas.microsoft.com/office/drawing/2010/main" xmlns="" w="9525">
                   <a:solidFill>
                     <a:srgbClr val="000000"/>
                   </a:solidFill>
@@ -3741,7 +3742,7 @@
             </a:ln>
             <a:extLst>
               <a:ext uri="{91240B29-F687-4f45-9708-019B960494DF}">
-                <a14:hiddenLine xmlns="" xmlns:a14="http://schemas.microsoft.com/office/drawing/2010/main" w="9525">
+                <a14:hiddenLine xmlns:a14="http://schemas.microsoft.com/office/drawing/2010/main" xmlns="" w="9525">
                   <a:solidFill>
                     <a:srgbClr val="000000"/>
                   </a:solidFill>
@@ -3838,7 +3839,7 @@
             </a:ln>
             <a:extLst>
               <a:ext uri="{91240B29-F687-4f45-9708-019B960494DF}">
-                <a14:hiddenLine xmlns="" xmlns:a14="http://schemas.microsoft.com/office/drawing/2010/main" w="9525">
+                <a14:hiddenLine xmlns:a14="http://schemas.microsoft.com/office/drawing/2010/main" xmlns="" w="9525">
                   <a:solidFill>
                     <a:srgbClr val="000000"/>
                   </a:solidFill>
@@ -3935,7 +3936,7 @@
             </a:ln>
             <a:extLst>
               <a:ext uri="{91240B29-F687-4f45-9708-019B960494DF}">
-                <a14:hiddenLine xmlns="" xmlns:a14="http://schemas.microsoft.com/office/drawing/2010/main" w="9525">
+                <a14:hiddenLine xmlns:a14="http://schemas.microsoft.com/office/drawing/2010/main" xmlns="" w="9525">
                   <a:solidFill>
                     <a:srgbClr val="000000"/>
                   </a:solidFill>
@@ -4007,7 +4008,7 @@
             </a:ln>
             <a:extLst>
               <a:ext uri="{91240B29-F687-4f45-9708-019B960494DF}">
-                <a14:hiddenLine xmlns="" xmlns:a14="http://schemas.microsoft.com/office/drawing/2010/main" w="9525">
+                <a14:hiddenLine xmlns:a14="http://schemas.microsoft.com/office/drawing/2010/main" xmlns="" w="9525">
                   <a:solidFill>
                     <a:srgbClr val="000000"/>
                   </a:solidFill>
@@ -4076,7 +4077,7 @@
             </a:ln>
             <a:extLst>
               <a:ext uri="{91240B29-F687-4f45-9708-019B960494DF}">
-                <a14:hiddenLine xmlns="" xmlns:a14="http://schemas.microsoft.com/office/drawing/2010/main" w="9525">
+                <a14:hiddenLine xmlns:a14="http://schemas.microsoft.com/office/drawing/2010/main" xmlns="" w="9525">
                   <a:solidFill>
                     <a:srgbClr val="000000"/>
                   </a:solidFill>
@@ -4173,7 +4174,7 @@
             </a:ln>
             <a:extLst>
               <a:ext uri="{91240B29-F687-4f45-9708-019B960494DF}">
-                <a14:hiddenLine xmlns="" xmlns:a14="http://schemas.microsoft.com/office/drawing/2010/main" w="9525">
+                <a14:hiddenLine xmlns:a14="http://schemas.microsoft.com/office/drawing/2010/main" xmlns="" w="9525">
                   <a:solidFill>
                     <a:srgbClr val="000000"/>
                   </a:solidFill>
@@ -4270,7 +4271,7 @@
             </a:ln>
             <a:extLst>
               <a:ext uri="{91240B29-F687-4f45-9708-019B960494DF}">
-                <a14:hiddenLine xmlns="" xmlns:a14="http://schemas.microsoft.com/office/drawing/2010/main" w="9525">
+                <a14:hiddenLine xmlns:a14="http://schemas.microsoft.com/office/drawing/2010/main" xmlns="" w="9525">
                   <a:solidFill>
                     <a:srgbClr val="000000"/>
                   </a:solidFill>
@@ -4339,7 +4340,7 @@
             </a:ln>
             <a:extLst>
               <a:ext uri="{91240B29-F687-4f45-9708-019B960494DF}">
-                <a14:hiddenLine xmlns="" xmlns:a14="http://schemas.microsoft.com/office/drawing/2010/main" w="9525">
+                <a14:hiddenLine xmlns:a14="http://schemas.microsoft.com/office/drawing/2010/main" xmlns="" w="9525">
                   <a:solidFill>
                     <a:srgbClr val="000000"/>
                   </a:solidFill>
@@ -4466,7 +4467,7 @@
             </a:ln>
             <a:extLst>
               <a:ext uri="{91240B29-F687-4f45-9708-019B960494DF}">
-                <a14:hiddenLine xmlns="" xmlns:a14="http://schemas.microsoft.com/office/drawing/2010/main" w="9525">
+                <a14:hiddenLine xmlns:a14="http://schemas.microsoft.com/office/drawing/2010/main" xmlns="" w="9525">
                   <a:solidFill>
                     <a:srgbClr val="000000"/>
                   </a:solidFill>
@@ -4541,7 +4542,7 @@
             </a:ln>
             <a:extLst>
               <a:ext uri="{91240B29-F687-4f45-9708-019B960494DF}">
-                <a14:hiddenLine xmlns="" xmlns:a14="http://schemas.microsoft.com/office/drawing/2010/main" w="9525">
+                <a14:hiddenLine xmlns:a14="http://schemas.microsoft.com/office/drawing/2010/main" xmlns="" w="9525">
                   <a:solidFill>
                     <a:srgbClr val="000000"/>
                   </a:solidFill>
@@ -4638,7 +4639,7 @@
             </a:ln>
             <a:extLst>
               <a:ext uri="{91240B29-F687-4f45-9708-019B960494DF}">
-                <a14:hiddenLine xmlns="" xmlns:a14="http://schemas.microsoft.com/office/drawing/2010/main" w="9525">
+                <a14:hiddenLine xmlns:a14="http://schemas.microsoft.com/office/drawing/2010/main" xmlns="" w="9525">
                   <a:solidFill>
                     <a:srgbClr val="000000"/>
                   </a:solidFill>
@@ -4785,7 +4786,7 @@
           <a:p>
             <a:fld id="{48A87A34-81AB-432B-8DAE-1953F412C126}" type="datetimeFigureOut">
               <a:rPr lang="en-US" dirty="0"/>
-              <a:t>7/28/2026</a:t>
+              <a:t>8/9/2026</a:t>
             </a:fld>
             <a:endParaRPr lang="en-US" dirty="0"/>
           </a:p>
@@ -5047,7 +5048,7 @@
           <a:p>
             <a:fld id="{48A87A34-81AB-432B-8DAE-1953F412C126}" type="datetimeFigureOut">
               <a:rPr lang="en-US" dirty="0"/>
-              <a:t>7/28/2026</a:t>
+              <a:t>8/9/2026</a:t>
             </a:fld>
             <a:endParaRPr lang="en-US" dirty="0"/>
           </a:p>
@@ -5238,7 +5239,7 @@
           <a:p>
             <a:fld id="{48A87A34-81AB-432B-8DAE-1953F412C126}" type="datetimeFigureOut">
               <a:rPr lang="en-US" dirty="0"/>
-              <a:t>7/28/2026</a:t>
+              <a:t>8/9/2026</a:t>
             </a:fld>
             <a:endParaRPr lang="en-US" dirty="0"/>
           </a:p>
@@ -5496,7 +5497,7 @@
           <a:p>
             <a:fld id="{48A87A34-81AB-432B-8DAE-1953F412C126}" type="datetimeFigureOut">
               <a:rPr lang="en-US" dirty="0"/>
-              <a:t>7/28/2026</a:t>
+              <a:t>8/9/2026</a:t>
             </a:fld>
             <a:endParaRPr lang="en-US" dirty="0"/>
           </a:p>
@@ -5925,7 +5926,7 @@
           <a:p>
             <a:fld id="{48A87A34-81AB-432B-8DAE-1953F412C126}" type="datetimeFigureOut">
               <a:rPr lang="en-US" dirty="0"/>
-              <a:t>7/28/2026</a:t>
+              <a:t>8/9/2026</a:t>
             </a:fld>
             <a:endParaRPr lang="en-US" dirty="0"/>
           </a:p>
@@ -6466,7 +6467,7 @@
           <a:p>
             <a:fld id="{48A87A34-81AB-432B-8DAE-1953F412C126}" type="datetimeFigureOut">
               <a:rPr lang="en-US" dirty="0"/>
-              <a:t>7/28/2026</a:t>
+              <a:t>8/9/2026</a:t>
             </a:fld>
             <a:endParaRPr lang="en-US" dirty="0"/>
           </a:p>
@@ -7181,7 +7182,7 @@
           <a:p>
             <a:fld id="{48A87A34-81AB-432B-8DAE-1953F412C126}" type="datetimeFigureOut">
               <a:rPr lang="en-US" dirty="0"/>
-              <a:t>7/28/2026</a:t>
+              <a:t>8/9/2026</a:t>
             </a:fld>
             <a:endParaRPr lang="en-US" dirty="0"/>
           </a:p>
@@ -7346,7 +7347,7 @@
           <a:p>
             <a:fld id="{48A87A34-81AB-432B-8DAE-1953F412C126}" type="datetimeFigureOut">
               <a:rPr lang="en-US" dirty="0"/>
-              <a:t>7/28/2026</a:t>
+              <a:t>8/9/2026</a:t>
             </a:fld>
             <a:endParaRPr lang="en-US" dirty="0"/>
           </a:p>
@@ -7521,7 +7522,7 @@
           <a:p>
             <a:fld id="{48A87A34-81AB-432B-8DAE-1953F412C126}" type="datetimeFigureOut">
               <a:rPr lang="en-US" dirty="0"/>
-              <a:t>7/28/2026</a:t>
+              <a:t>8/9/2026</a:t>
             </a:fld>
             <a:endParaRPr lang="en-US" dirty="0"/>
           </a:p>
@@ -7686,7 +7687,7 @@
           <a:p>
             <a:fld id="{48A87A34-81AB-432B-8DAE-1953F412C126}" type="datetimeFigureOut">
               <a:rPr lang="en-US" dirty="0"/>
-              <a:t>7/28/2026</a:t>
+              <a:t>8/9/2026</a:t>
             </a:fld>
             <a:endParaRPr lang="en-US" dirty="0"/>
           </a:p>
@@ -7931,7 +7932,7 @@
           <a:p>
             <a:fld id="{48A87A34-81AB-432B-8DAE-1953F412C126}" type="datetimeFigureOut">
               <a:rPr lang="en-US" dirty="0"/>
-              <a:t>7/28/2026</a:t>
+              <a:t>8/9/2026</a:t>
             </a:fld>
             <a:endParaRPr lang="en-US" dirty="0"/>
           </a:p>
@@ -8158,7 +8159,7 @@
           <a:p>
             <a:fld id="{48A87A34-81AB-432B-8DAE-1953F412C126}" type="datetimeFigureOut">
               <a:rPr lang="en-US" dirty="0"/>
-              <a:t>7/28/2026</a:t>
+              <a:t>8/9/2026</a:t>
             </a:fld>
             <a:endParaRPr lang="en-US" dirty="0"/>
           </a:p>
@@ -8534,7 +8535,7 @@
           <a:p>
             <a:fld id="{48A87A34-81AB-432B-8DAE-1953F412C126}" type="datetimeFigureOut">
               <a:rPr lang="en-US" dirty="0"/>
-              <a:t>7/28/2026</a:t>
+              <a:t>8/9/2026</a:t>
             </a:fld>
             <a:endParaRPr lang="en-US" dirty="0"/>
           </a:p>
@@ -8647,7 +8648,7 @@
           <a:p>
             <a:fld id="{48A87A34-81AB-432B-8DAE-1953F412C126}" type="datetimeFigureOut">
               <a:rPr lang="en-US" dirty="0"/>
-              <a:t>7/28/2026</a:t>
+              <a:t>8/9/2026</a:t>
             </a:fld>
             <a:endParaRPr lang="en-US" dirty="0"/>
           </a:p>
@@ -8737,7 +8738,7 @@
           <a:p>
             <a:fld id="{48A87A34-81AB-432B-8DAE-1953F412C126}" type="datetimeFigureOut">
               <a:rPr lang="en-US" dirty="0"/>
-              <a:t>7/28/2026</a:t>
+              <a:t>8/9/2026</a:t>
             </a:fld>
             <a:endParaRPr lang="en-US" dirty="0"/>
           </a:p>
@@ -8981,7 +8982,7 @@
           <a:p>
             <a:fld id="{48A87A34-81AB-432B-8DAE-1953F412C126}" type="datetimeFigureOut">
               <a:rPr lang="en-US" dirty="0"/>
-              <a:t>7/28/2026</a:t>
+              <a:t>8/9/2026</a:t>
             </a:fld>
             <a:endParaRPr lang="en-US" dirty="0"/>
           </a:p>
@@ -9256,7 +9257,7 @@
           <a:p>
             <a:fld id="{48A87A34-81AB-432B-8DAE-1953F412C126}" type="datetimeFigureOut">
               <a:rPr lang="en-US" dirty="0"/>
-              <a:t>7/28/2026</a:t>
+              <a:t>8/9/2026</a:t>
             </a:fld>
             <a:endParaRPr lang="en-US" dirty="0"/>
           </a:p>
@@ -9367,7 +9368,7 @@
           <a:noFill/>
           <a:extLst>
             <a:ext uri="{909E8E84-426E-40dd-AFC4-6F175D3DCCD1}">
-              <a14:hiddenFill xmlns="" xmlns:a14="http://schemas.microsoft.com/office/drawing/2010/main">
+              <a14:hiddenFill xmlns:a14="http://schemas.microsoft.com/office/drawing/2010/main" xmlns="">
                 <a:solidFill>
                   <a:srgbClr val="FFFFFF"/>
                 </a:solidFill>
@@ -9441,7 +9442,7 @@
               </a:ln>
               <a:extLst>
                 <a:ext uri="{91240B29-F687-4f45-9708-019B960494DF}">
-                  <a14:hiddenLine xmlns="" xmlns:a14="http://schemas.microsoft.com/office/drawing/2010/main" w="9525">
+                  <a14:hiddenLine xmlns:a14="http://schemas.microsoft.com/office/drawing/2010/main" xmlns="" w="9525">
                     <a:solidFill>
                       <a:srgbClr val="000000"/>
                     </a:solidFill>
@@ -9538,7 +9539,7 @@
               </a:ln>
               <a:extLst>
                 <a:ext uri="{91240B29-F687-4f45-9708-019B960494DF}">
-                  <a14:hiddenLine xmlns="" xmlns:a14="http://schemas.microsoft.com/office/drawing/2010/main" w="9525">
+                  <a14:hiddenLine xmlns:a14="http://schemas.microsoft.com/office/drawing/2010/main" xmlns="" w="9525">
                     <a:solidFill>
                       <a:srgbClr val="000000"/>
                     </a:solidFill>
@@ -9635,7 +9636,7 @@
               </a:ln>
               <a:extLst>
                 <a:ext uri="{91240B29-F687-4f45-9708-019B960494DF}">
-                  <a14:hiddenLine xmlns="" xmlns:a14="http://schemas.microsoft.com/office/drawing/2010/main" w="9525">
+                  <a14:hiddenLine xmlns:a14="http://schemas.microsoft.com/office/drawing/2010/main" xmlns="" w="9525">
                     <a:solidFill>
                       <a:srgbClr val="000000"/>
                     </a:solidFill>
@@ -9704,7 +9705,7 @@
               </a:ln>
               <a:extLst>
                 <a:ext uri="{91240B29-F687-4f45-9708-019B960494DF}">
-                  <a14:hiddenLine xmlns="" xmlns:a14="http://schemas.microsoft.com/office/drawing/2010/main" w="9525">
+                  <a14:hiddenLine xmlns:a14="http://schemas.microsoft.com/office/drawing/2010/main" xmlns="" w="9525">
                     <a:solidFill>
                       <a:srgbClr val="000000"/>
                     </a:solidFill>
@@ -9801,7 +9802,7 @@
               </a:ln>
               <a:extLst>
                 <a:ext uri="{91240B29-F687-4f45-9708-019B960494DF}">
-                  <a14:hiddenLine xmlns="" xmlns:a14="http://schemas.microsoft.com/office/drawing/2010/main" w="9525">
+                  <a14:hiddenLine xmlns:a14="http://schemas.microsoft.com/office/drawing/2010/main" xmlns="" w="9525">
                     <a:solidFill>
                       <a:srgbClr val="000000"/>
                     </a:solidFill>
@@ -9870,7 +9871,7 @@
               </a:ln>
               <a:extLst>
                 <a:ext uri="{91240B29-F687-4f45-9708-019B960494DF}">
-                  <a14:hiddenLine xmlns="" xmlns:a14="http://schemas.microsoft.com/office/drawing/2010/main" w="9525">
+                  <a14:hiddenLine xmlns:a14="http://schemas.microsoft.com/office/drawing/2010/main" xmlns="" w="9525">
                     <a:solidFill>
                       <a:srgbClr val="000000"/>
                     </a:solidFill>
@@ -9939,7 +9940,7 @@
               </a:ln>
               <a:extLst>
                 <a:ext uri="{91240B29-F687-4f45-9708-019B960494DF}">
-                  <a14:hiddenLine xmlns="" xmlns:a14="http://schemas.microsoft.com/office/drawing/2010/main" w="9525">
+                  <a14:hiddenLine xmlns:a14="http://schemas.microsoft.com/office/drawing/2010/main" xmlns="" w="9525">
                     <a:solidFill>
                       <a:srgbClr val="000000"/>
                     </a:solidFill>
@@ -10036,7 +10037,7 @@
               </a:ln>
               <a:extLst>
                 <a:ext uri="{91240B29-F687-4f45-9708-019B960494DF}">
-                  <a14:hiddenLine xmlns="" xmlns:a14="http://schemas.microsoft.com/office/drawing/2010/main" w="9525">
+                  <a14:hiddenLine xmlns:a14="http://schemas.microsoft.com/office/drawing/2010/main" xmlns="" w="9525">
                     <a:solidFill>
                       <a:srgbClr val="000000"/>
                     </a:solidFill>
@@ -10133,7 +10134,7 @@
               </a:ln>
               <a:extLst>
                 <a:ext uri="{91240B29-F687-4f45-9708-019B960494DF}">
-                  <a14:hiddenLine xmlns="" xmlns:a14="http://schemas.microsoft.com/office/drawing/2010/main" w="9525">
+                  <a14:hiddenLine xmlns:a14="http://schemas.microsoft.com/office/drawing/2010/main" xmlns="" w="9525">
                     <a:solidFill>
                       <a:srgbClr val="000000"/>
                     </a:solidFill>
@@ -10202,7 +10203,7 @@
               </a:ln>
               <a:extLst>
                 <a:ext uri="{91240B29-F687-4f45-9708-019B960494DF}">
-                  <a14:hiddenLine xmlns="" xmlns:a14="http://schemas.microsoft.com/office/drawing/2010/main" w="9525">
+                  <a14:hiddenLine xmlns:a14="http://schemas.microsoft.com/office/drawing/2010/main" xmlns="" w="9525">
                     <a:solidFill>
                       <a:srgbClr val="000000"/>
                     </a:solidFill>
@@ -10319,7 +10320,7 @@
               </a:ln>
               <a:extLst>
                 <a:ext uri="{91240B29-F687-4f45-9708-019B960494DF}">
-                  <a14:hiddenLine xmlns="" xmlns:a14="http://schemas.microsoft.com/office/drawing/2010/main" w="9525">
+                  <a14:hiddenLine xmlns:a14="http://schemas.microsoft.com/office/drawing/2010/main" xmlns="" w="9525">
                     <a:solidFill>
                       <a:srgbClr val="000000"/>
                     </a:solidFill>
@@ -10417,7 +10418,7 @@
               </a:ln>
               <a:extLst>
                 <a:ext uri="{91240B29-F687-4f45-9708-019B960494DF}">
-                  <a14:hiddenLine xmlns="" xmlns:a14="http://schemas.microsoft.com/office/drawing/2010/main" w="9525">
+                  <a14:hiddenLine xmlns:a14="http://schemas.microsoft.com/office/drawing/2010/main" xmlns="" w="9525">
                     <a:solidFill>
                       <a:srgbClr val="000000"/>
                     </a:solidFill>
@@ -10486,7 +10487,7 @@
               </a:ln>
               <a:extLst>
                 <a:ext uri="{91240B29-F687-4f45-9708-019B960494DF}">
-                  <a14:hiddenLine xmlns="" xmlns:a14="http://schemas.microsoft.com/office/drawing/2010/main" w="9525">
+                  <a14:hiddenLine xmlns:a14="http://schemas.microsoft.com/office/drawing/2010/main" xmlns="" w="9525">
                     <a:solidFill>
                       <a:srgbClr val="000000"/>
                     </a:solidFill>
@@ -10555,7 +10556,7 @@
               </a:ln>
               <a:extLst>
                 <a:ext uri="{91240B29-F687-4f45-9708-019B960494DF}">
-                  <a14:hiddenLine xmlns="" xmlns:a14="http://schemas.microsoft.com/office/drawing/2010/main" w="9525">
+                  <a14:hiddenLine xmlns:a14="http://schemas.microsoft.com/office/drawing/2010/main" xmlns="" w="9525">
                     <a:solidFill>
                       <a:srgbClr val="000000"/>
                     </a:solidFill>
@@ -10652,7 +10653,7 @@
               </a:ln>
               <a:extLst>
                 <a:ext uri="{91240B29-F687-4f45-9708-019B960494DF}">
-                  <a14:hiddenLine xmlns="" xmlns:a14="http://schemas.microsoft.com/office/drawing/2010/main" w="9525">
+                  <a14:hiddenLine xmlns:a14="http://schemas.microsoft.com/office/drawing/2010/main" xmlns="" w="9525">
                     <a:solidFill>
                       <a:srgbClr val="000000"/>
                     </a:solidFill>
@@ -10693,7 +10694,7 @@
               </a:ln>
               <a:extLst>
                 <a:ext uri="{91240B29-F687-4f45-9708-019B960494DF}">
-                  <a14:hiddenLine xmlns="" xmlns:a14="http://schemas.microsoft.com/office/drawing/2010/main" w="9525">
+                  <a14:hiddenLine xmlns:a14="http://schemas.microsoft.com/office/drawing/2010/main" xmlns="" w="9525">
                     <a:solidFill>
                       <a:srgbClr val="000000"/>
                     </a:solidFill>
@@ -10765,7 +10766,7 @@
               </a:ln>
               <a:extLst>
                 <a:ext uri="{91240B29-F687-4f45-9708-019B960494DF}">
-                  <a14:hiddenLine xmlns="" xmlns:a14="http://schemas.microsoft.com/office/drawing/2010/main" w="9525">
+                  <a14:hiddenLine xmlns:a14="http://schemas.microsoft.com/office/drawing/2010/main" xmlns="" w="9525">
                     <a:solidFill>
                       <a:srgbClr val="000000"/>
                     </a:solidFill>
@@ -10862,7 +10863,7 @@
               </a:ln>
               <a:extLst>
                 <a:ext uri="{91240B29-F687-4f45-9708-019B960494DF}">
-                  <a14:hiddenLine xmlns="" xmlns:a14="http://schemas.microsoft.com/office/drawing/2010/main" w="9525">
+                  <a14:hiddenLine xmlns:a14="http://schemas.microsoft.com/office/drawing/2010/main" xmlns="" w="9525">
                     <a:solidFill>
                       <a:srgbClr val="000000"/>
                     </a:solidFill>
@@ -10931,7 +10932,7 @@
               </a:ln>
               <a:extLst>
                 <a:ext uri="{91240B29-F687-4f45-9708-019B960494DF}">
-                  <a14:hiddenLine xmlns="" xmlns:a14="http://schemas.microsoft.com/office/drawing/2010/main" w="9525">
+                  <a14:hiddenLine xmlns:a14="http://schemas.microsoft.com/office/drawing/2010/main" xmlns="" w="9525">
                     <a:solidFill>
                       <a:srgbClr val="000000"/>
                     </a:solidFill>
@@ -11028,7 +11029,7 @@
               </a:ln>
               <a:extLst>
                 <a:ext uri="{91240B29-F687-4f45-9708-019B960494DF}">
-                  <a14:hiddenLine xmlns="" xmlns:a14="http://schemas.microsoft.com/office/drawing/2010/main" w="9525">
+                  <a14:hiddenLine xmlns:a14="http://schemas.microsoft.com/office/drawing/2010/main" xmlns="" w="9525">
                     <a:solidFill>
                       <a:srgbClr val="000000"/>
                     </a:solidFill>
@@ -11100,7 +11101,7 @@
               </a:ln>
               <a:extLst>
                 <a:ext uri="{91240B29-F687-4f45-9708-019B960494DF}">
-                  <a14:hiddenLine xmlns="" xmlns:a14="http://schemas.microsoft.com/office/drawing/2010/main" w="9525">
+                  <a14:hiddenLine xmlns:a14="http://schemas.microsoft.com/office/drawing/2010/main" xmlns="" w="9525">
                     <a:solidFill>
                       <a:srgbClr val="000000"/>
                     </a:solidFill>
@@ -11169,7 +11170,7 @@
               </a:ln>
               <a:extLst>
                 <a:ext uri="{91240B29-F687-4f45-9708-019B960494DF}">
-                  <a14:hiddenLine xmlns="" xmlns:a14="http://schemas.microsoft.com/office/drawing/2010/main" w="9525">
+                  <a14:hiddenLine xmlns:a14="http://schemas.microsoft.com/office/drawing/2010/main" xmlns="" w="9525">
                     <a:solidFill>
                       <a:srgbClr val="000000"/>
                     </a:solidFill>
@@ -11266,7 +11267,7 @@
               </a:ln>
               <a:extLst>
                 <a:ext uri="{91240B29-F687-4f45-9708-019B960494DF}">
-                  <a14:hiddenLine xmlns="" xmlns:a14="http://schemas.microsoft.com/office/drawing/2010/main" w="9525">
+                  <a14:hiddenLine xmlns:a14="http://schemas.microsoft.com/office/drawing/2010/main" xmlns="" w="9525">
                     <a:solidFill>
                       <a:srgbClr val="000000"/>
                     </a:solidFill>
@@ -11363,7 +11364,7 @@
               </a:ln>
               <a:extLst>
                 <a:ext uri="{91240B29-F687-4f45-9708-019B960494DF}">
-                  <a14:hiddenLine xmlns="" xmlns:a14="http://schemas.microsoft.com/office/drawing/2010/main" w="9525">
+                  <a14:hiddenLine xmlns:a14="http://schemas.microsoft.com/office/drawing/2010/main" xmlns="" w="9525">
                     <a:solidFill>
                       <a:srgbClr val="000000"/>
                     </a:solidFill>
@@ -11435,7 +11436,7 @@
               </a:ln>
               <a:extLst>
                 <a:ext uri="{91240B29-F687-4f45-9708-019B960494DF}">
-                  <a14:hiddenLine xmlns="" xmlns:a14="http://schemas.microsoft.com/office/drawing/2010/main" w="9525">
+                  <a14:hiddenLine xmlns:a14="http://schemas.microsoft.com/office/drawing/2010/main" xmlns="" w="9525">
                     <a:solidFill>
                       <a:srgbClr val="000000"/>
                     </a:solidFill>
@@ -11562,7 +11563,7 @@
               </a:ln>
               <a:extLst>
                 <a:ext uri="{91240B29-F687-4f45-9708-019B960494DF}">
-                  <a14:hiddenLine xmlns="" xmlns:a14="http://schemas.microsoft.com/office/drawing/2010/main" w="9525">
+                  <a14:hiddenLine xmlns:a14="http://schemas.microsoft.com/office/drawing/2010/main" xmlns="" w="9525">
                     <a:solidFill>
                       <a:srgbClr val="000000"/>
                     </a:solidFill>
@@ -11667,7 +11668,7 @@
               </a:ln>
               <a:extLst>
                 <a:ext uri="{91240B29-F687-4f45-9708-019B960494DF}">
-                  <a14:hiddenLine xmlns="" xmlns:a14="http://schemas.microsoft.com/office/drawing/2010/main" w="9525">
+                  <a14:hiddenLine xmlns:a14="http://schemas.microsoft.com/office/drawing/2010/main" xmlns="" w="9525">
                     <a:solidFill>
                       <a:srgbClr val="000000"/>
                     </a:solidFill>
@@ -11789,7 +11790,7 @@
               </a:ln>
               <a:extLst>
                 <a:ext uri="{91240B29-F687-4f45-9708-019B960494DF}">
-                  <a14:hiddenLine xmlns="" xmlns:a14="http://schemas.microsoft.com/office/drawing/2010/main" w="9525">
+                  <a14:hiddenLine xmlns:a14="http://schemas.microsoft.com/office/drawing/2010/main" xmlns="" w="9525">
                     <a:solidFill>
                       <a:srgbClr val="000000"/>
                     </a:solidFill>
@@ -11886,7 +11887,7 @@
               </a:ln>
               <a:extLst>
                 <a:ext uri="{91240B29-F687-4f45-9708-019B960494DF}">
-                  <a14:hiddenLine xmlns="" xmlns:a14="http://schemas.microsoft.com/office/drawing/2010/main" w="9525">
+                  <a14:hiddenLine xmlns:a14="http://schemas.microsoft.com/office/drawing/2010/main" xmlns="" w="9525">
                     <a:solidFill>
                       <a:srgbClr val="000000"/>
                     </a:solidFill>
@@ -11958,7 +11959,7 @@
               </a:ln>
               <a:extLst>
                 <a:ext uri="{91240B29-F687-4f45-9708-019B960494DF}">
-                  <a14:hiddenLine xmlns="" xmlns:a14="http://schemas.microsoft.com/office/drawing/2010/main" w="9525">
+                  <a14:hiddenLine xmlns:a14="http://schemas.microsoft.com/office/drawing/2010/main" xmlns="" w="9525">
                     <a:solidFill>
                       <a:srgbClr val="000000"/>
                     </a:solidFill>
@@ -12055,7 +12056,7 @@
               </a:ln>
               <a:extLst>
                 <a:ext uri="{91240B29-F687-4f45-9708-019B960494DF}">
-                  <a14:hiddenLine xmlns="" xmlns:a14="http://schemas.microsoft.com/office/drawing/2010/main" w="9525">
+                  <a14:hiddenLine xmlns:a14="http://schemas.microsoft.com/office/drawing/2010/main" xmlns="" w="9525">
                     <a:solidFill>
                       <a:srgbClr val="000000"/>
                     </a:solidFill>
@@ -12130,7 +12131,7 @@
               </a:ln>
               <a:extLst>
                 <a:ext uri="{91240B29-F687-4f45-9708-019B960494DF}">
-                  <a14:hiddenLine xmlns="" xmlns:a14="http://schemas.microsoft.com/office/drawing/2010/main" w="9525">
+                  <a14:hiddenLine xmlns:a14="http://schemas.microsoft.com/office/drawing/2010/main" xmlns="" w="9525">
                     <a:solidFill>
                       <a:srgbClr val="000000"/>
                     </a:solidFill>
@@ -12227,7 +12228,7 @@
               </a:ln>
               <a:extLst>
                 <a:ext uri="{91240B29-F687-4f45-9708-019B960494DF}">
-                  <a14:hiddenLine xmlns="" xmlns:a14="http://schemas.microsoft.com/office/drawing/2010/main" w="9525">
+                  <a14:hiddenLine xmlns:a14="http://schemas.microsoft.com/office/drawing/2010/main" xmlns="" w="9525">
                     <a:solidFill>
                       <a:srgbClr val="000000"/>
                     </a:solidFill>
@@ -12302,7 +12303,7 @@
               </a:ln>
               <a:extLst>
                 <a:ext uri="{91240B29-F687-4f45-9708-019B960494DF}">
-                  <a14:hiddenLine xmlns="" xmlns:a14="http://schemas.microsoft.com/office/drawing/2010/main" w="9525">
+                  <a14:hiddenLine xmlns:a14="http://schemas.microsoft.com/office/drawing/2010/main" xmlns="" w="9525">
                     <a:solidFill>
                       <a:srgbClr val="000000"/>
                     </a:solidFill>
@@ -12399,7 +12400,7 @@
               </a:ln>
               <a:extLst>
                 <a:ext uri="{91240B29-F687-4f45-9708-019B960494DF}">
-                  <a14:hiddenLine xmlns="" xmlns:a14="http://schemas.microsoft.com/office/drawing/2010/main" w="9525">
+                  <a14:hiddenLine xmlns:a14="http://schemas.microsoft.com/office/drawing/2010/main" xmlns="" w="9525">
                     <a:solidFill>
                       <a:srgbClr val="000000"/>
                     </a:solidFill>
@@ -12440,7 +12441,7 @@
               </a:ln>
               <a:extLst>
                 <a:ext uri="{91240B29-F687-4f45-9708-019B960494DF}">
-                  <a14:hiddenLine xmlns="" xmlns:a14="http://schemas.microsoft.com/office/drawing/2010/main" w="9525">
+                  <a14:hiddenLine xmlns:a14="http://schemas.microsoft.com/office/drawing/2010/main" xmlns="" w="9525">
                     <a:solidFill>
                       <a:srgbClr val="000000"/>
                     </a:solidFill>
@@ -12588,7 +12589,7 @@
             <a:fld id="{48A87A34-81AB-432B-8DAE-1953F412C126}" type="datetimeFigureOut">
               <a:rPr lang="en-US" dirty="0"/>
               <a:pPr/>
-              <a:t>7/28/2026</a:t>
+              <a:t>8/9/2026</a:t>
             </a:fld>
             <a:endParaRPr lang="en-US" dirty="0"/>
           </a:p>
@@ -13466,7 +13467,7 @@
           <a:noFill/>
           <a:extLst>
             <a:ext uri="{909E8E84-426E-40dd-AFC4-6F175D3DCCD1}">
-              <a14:hiddenFill xmlns:a14="http://schemas.microsoft.com/office/drawing/2010/main" xmlns:p14="http://schemas.microsoft.com/office/powerpoint/2010/main" xmlns:a16="http://schemas.microsoft.com/office/drawing/2014/main" xmlns="">
+              <a14:hiddenFill xmlns="" xmlns:a16="http://schemas.microsoft.com/office/drawing/2014/main" xmlns:p14="http://schemas.microsoft.com/office/powerpoint/2010/main" xmlns:a14="http://schemas.microsoft.com/office/drawing/2010/main">
                 <a:solidFill>
                   <a:srgbClr val="FFFFFF"/>
                 </a:solidFill>
@@ -13710,7 +13711,7 @@
             </a:ln>
             <a:extLst>
               <a:ext uri="{91240B29-F687-4f45-9708-019B960494DF}">
-                <a14:hiddenLine xmlns:a14="http://schemas.microsoft.com/office/drawing/2010/main" xmlns:p14="http://schemas.microsoft.com/office/powerpoint/2010/main" xmlns:a16="http://schemas.microsoft.com/office/drawing/2014/main" xmlns="" w="9525">
+                <a14:hiddenLine xmlns="" xmlns:a16="http://schemas.microsoft.com/office/drawing/2014/main" xmlns:p14="http://schemas.microsoft.com/office/powerpoint/2010/main" xmlns:a14="http://schemas.microsoft.com/office/drawing/2010/main" w="9525">
                   <a:solidFill>
                     <a:srgbClr val="000000"/>
                   </a:solidFill>
@@ -13822,7 +13823,7 @@
             </a:ln>
             <a:extLst>
               <a:ext uri="{91240B29-F687-4f45-9708-019B960494DF}">
-                <a14:hiddenLine xmlns:a14="http://schemas.microsoft.com/office/drawing/2010/main" xmlns:p14="http://schemas.microsoft.com/office/powerpoint/2010/main" xmlns:a16="http://schemas.microsoft.com/office/drawing/2014/main" xmlns="" w="9525">
+                <a14:hiddenLine xmlns="" xmlns:a16="http://schemas.microsoft.com/office/drawing/2014/main" xmlns:p14="http://schemas.microsoft.com/office/powerpoint/2010/main" xmlns:a14="http://schemas.microsoft.com/office/drawing/2010/main" w="9525">
                   <a:solidFill>
                     <a:srgbClr val="000000"/>
                   </a:solidFill>
@@ -13934,7 +13935,7 @@
             </a:ln>
             <a:extLst>
               <a:ext uri="{91240B29-F687-4f45-9708-019B960494DF}">
-                <a14:hiddenLine xmlns:a14="http://schemas.microsoft.com/office/drawing/2010/main" xmlns:p14="http://schemas.microsoft.com/office/powerpoint/2010/main" xmlns:a16="http://schemas.microsoft.com/office/drawing/2014/main" xmlns="" w="9525">
+                <a14:hiddenLine xmlns="" xmlns:a16="http://schemas.microsoft.com/office/drawing/2014/main" xmlns:p14="http://schemas.microsoft.com/office/powerpoint/2010/main" xmlns:a14="http://schemas.microsoft.com/office/drawing/2010/main" w="9525">
                   <a:solidFill>
                     <a:srgbClr val="000000"/>
                   </a:solidFill>
@@ -14018,7 +14019,7 @@
             </a:ln>
             <a:extLst>
               <a:ext uri="{91240B29-F687-4f45-9708-019B960494DF}">
-                <a14:hiddenLine xmlns:a14="http://schemas.microsoft.com/office/drawing/2010/main" xmlns:p14="http://schemas.microsoft.com/office/powerpoint/2010/main" xmlns:a16="http://schemas.microsoft.com/office/drawing/2014/main" xmlns="" w="9525">
+                <a14:hiddenLine xmlns="" xmlns:a16="http://schemas.microsoft.com/office/drawing/2014/main" xmlns:p14="http://schemas.microsoft.com/office/powerpoint/2010/main" xmlns:a14="http://schemas.microsoft.com/office/drawing/2010/main" w="9525">
                   <a:solidFill>
                     <a:srgbClr val="000000"/>
                   </a:solidFill>
@@ -14130,7 +14131,7 @@
             </a:ln>
             <a:extLst>
               <a:ext uri="{91240B29-F687-4f45-9708-019B960494DF}">
-                <a14:hiddenLine xmlns:a14="http://schemas.microsoft.com/office/drawing/2010/main" xmlns:p14="http://schemas.microsoft.com/office/powerpoint/2010/main" xmlns:a16="http://schemas.microsoft.com/office/drawing/2014/main" xmlns="" w="9525">
+                <a14:hiddenLine xmlns="" xmlns:a16="http://schemas.microsoft.com/office/drawing/2014/main" xmlns:p14="http://schemas.microsoft.com/office/powerpoint/2010/main" xmlns:a14="http://schemas.microsoft.com/office/drawing/2010/main" w="9525">
                   <a:solidFill>
                     <a:srgbClr val="000000"/>
                   </a:solidFill>
@@ -14214,7 +14215,7 @@
             </a:ln>
             <a:extLst>
               <a:ext uri="{91240B29-F687-4f45-9708-019B960494DF}">
-                <a14:hiddenLine xmlns:a14="http://schemas.microsoft.com/office/drawing/2010/main" xmlns:p14="http://schemas.microsoft.com/office/powerpoint/2010/main" xmlns:a16="http://schemas.microsoft.com/office/drawing/2014/main" xmlns="" w="9525">
+                <a14:hiddenLine xmlns="" xmlns:a16="http://schemas.microsoft.com/office/drawing/2014/main" xmlns:p14="http://schemas.microsoft.com/office/powerpoint/2010/main" xmlns:a14="http://schemas.microsoft.com/office/drawing/2010/main" w="9525">
                   <a:solidFill>
                     <a:srgbClr val="000000"/>
                   </a:solidFill>
@@ -14298,7 +14299,7 @@
             </a:ln>
             <a:extLst>
               <a:ext uri="{91240B29-F687-4f45-9708-019B960494DF}">
-                <a14:hiddenLine xmlns:a14="http://schemas.microsoft.com/office/drawing/2010/main" xmlns:p14="http://schemas.microsoft.com/office/powerpoint/2010/main" xmlns:a16="http://schemas.microsoft.com/office/drawing/2014/main" xmlns="" w="9525">
+                <a14:hiddenLine xmlns="" xmlns:a16="http://schemas.microsoft.com/office/drawing/2014/main" xmlns:p14="http://schemas.microsoft.com/office/powerpoint/2010/main" xmlns:a14="http://schemas.microsoft.com/office/drawing/2010/main" w="9525">
                   <a:solidFill>
                     <a:srgbClr val="000000"/>
                   </a:solidFill>
@@ -14410,7 +14411,7 @@
             </a:ln>
             <a:extLst>
               <a:ext uri="{91240B29-F687-4f45-9708-019B960494DF}">
-                <a14:hiddenLine xmlns:a14="http://schemas.microsoft.com/office/drawing/2010/main" xmlns:p14="http://schemas.microsoft.com/office/powerpoint/2010/main" xmlns:a16="http://schemas.microsoft.com/office/drawing/2014/main" xmlns="" w="9525">
+                <a14:hiddenLine xmlns="" xmlns:a16="http://schemas.microsoft.com/office/drawing/2014/main" xmlns:p14="http://schemas.microsoft.com/office/powerpoint/2010/main" xmlns:a14="http://schemas.microsoft.com/office/drawing/2010/main" w="9525">
                   <a:solidFill>
                     <a:srgbClr val="000000"/>
                   </a:solidFill>
@@ -14522,7 +14523,7 @@
             </a:ln>
             <a:extLst>
               <a:ext uri="{91240B29-F687-4f45-9708-019B960494DF}">
-                <a14:hiddenLine xmlns:a14="http://schemas.microsoft.com/office/drawing/2010/main" xmlns:p14="http://schemas.microsoft.com/office/powerpoint/2010/main" xmlns:a16="http://schemas.microsoft.com/office/drawing/2014/main" xmlns="" w="9525">
+                <a14:hiddenLine xmlns="" xmlns:a16="http://schemas.microsoft.com/office/drawing/2014/main" xmlns:p14="http://schemas.microsoft.com/office/powerpoint/2010/main" xmlns:a14="http://schemas.microsoft.com/office/drawing/2010/main" w="9525">
                   <a:solidFill>
                     <a:srgbClr val="000000"/>
                   </a:solidFill>
@@ -14606,7 +14607,7 @@
             </a:ln>
             <a:extLst>
               <a:ext uri="{91240B29-F687-4f45-9708-019B960494DF}">
-                <a14:hiddenLine xmlns:a14="http://schemas.microsoft.com/office/drawing/2010/main" xmlns:p14="http://schemas.microsoft.com/office/powerpoint/2010/main" xmlns:a16="http://schemas.microsoft.com/office/drawing/2014/main" xmlns="" w="9525">
+                <a14:hiddenLine xmlns="" xmlns:a16="http://schemas.microsoft.com/office/drawing/2014/main" xmlns:p14="http://schemas.microsoft.com/office/powerpoint/2010/main" xmlns:a14="http://schemas.microsoft.com/office/drawing/2010/main" w="9525">
                   <a:solidFill>
                     <a:srgbClr val="000000"/>
                   </a:solidFill>
@@ -14738,7 +14739,7 @@
             </a:ln>
             <a:extLst>
               <a:ext uri="{91240B29-F687-4f45-9708-019B960494DF}">
-                <a14:hiddenLine xmlns:a14="http://schemas.microsoft.com/office/drawing/2010/main" xmlns:p14="http://schemas.microsoft.com/office/powerpoint/2010/main" xmlns:a16="http://schemas.microsoft.com/office/drawing/2014/main" xmlns="" w="9525">
+                <a14:hiddenLine xmlns="" xmlns:a16="http://schemas.microsoft.com/office/drawing/2014/main" xmlns:p14="http://schemas.microsoft.com/office/powerpoint/2010/main" xmlns:a14="http://schemas.microsoft.com/office/drawing/2010/main" w="9525">
                   <a:solidFill>
                     <a:srgbClr val="000000"/>
                   </a:solidFill>
@@ -14866,7 +14867,7 @@
             </a:ln>
             <a:extLst>
               <a:ext uri="{91240B29-F687-4f45-9708-019B960494DF}">
-                <a14:hiddenLine xmlns:a14="http://schemas.microsoft.com/office/drawing/2010/main" xmlns:p14="http://schemas.microsoft.com/office/powerpoint/2010/main" xmlns:a16="http://schemas.microsoft.com/office/drawing/2014/main" xmlns="" w="9525">
+                <a14:hiddenLine xmlns="" xmlns:a16="http://schemas.microsoft.com/office/drawing/2014/main" xmlns:p14="http://schemas.microsoft.com/office/powerpoint/2010/main" xmlns:a14="http://schemas.microsoft.com/office/drawing/2010/main" w="9525">
                   <a:solidFill>
                     <a:srgbClr val="000000"/>
                   </a:solidFill>
@@ -14950,7 +14951,7 @@
             </a:ln>
             <a:extLst>
               <a:ext uri="{91240B29-F687-4f45-9708-019B960494DF}">
-                <a14:hiddenLine xmlns:a14="http://schemas.microsoft.com/office/drawing/2010/main" xmlns:p14="http://schemas.microsoft.com/office/powerpoint/2010/main" xmlns:a16="http://schemas.microsoft.com/office/drawing/2014/main" xmlns="" w="9525">
+                <a14:hiddenLine xmlns="" xmlns:a16="http://schemas.microsoft.com/office/drawing/2014/main" xmlns:p14="http://schemas.microsoft.com/office/powerpoint/2010/main" xmlns:a14="http://schemas.microsoft.com/office/drawing/2010/main" w="9525">
                   <a:solidFill>
                     <a:srgbClr val="000000"/>
                   </a:solidFill>
@@ -15034,7 +15035,7 @@
             </a:ln>
             <a:extLst>
               <a:ext uri="{91240B29-F687-4f45-9708-019B960494DF}">
-                <a14:hiddenLine xmlns:a14="http://schemas.microsoft.com/office/drawing/2010/main" xmlns:p14="http://schemas.microsoft.com/office/powerpoint/2010/main" xmlns:a16="http://schemas.microsoft.com/office/drawing/2014/main" xmlns="" w="9525">
+                <a14:hiddenLine xmlns="" xmlns:a16="http://schemas.microsoft.com/office/drawing/2014/main" xmlns:p14="http://schemas.microsoft.com/office/powerpoint/2010/main" xmlns:a14="http://schemas.microsoft.com/office/drawing/2010/main" w="9525">
                   <a:solidFill>
                     <a:srgbClr val="000000"/>
                   </a:solidFill>
@@ -15146,7 +15147,7 @@
             </a:ln>
             <a:extLst>
               <a:ext uri="{91240B29-F687-4f45-9708-019B960494DF}">
-                <a14:hiddenLine xmlns:a14="http://schemas.microsoft.com/office/drawing/2010/main" xmlns:p14="http://schemas.microsoft.com/office/powerpoint/2010/main" xmlns:a16="http://schemas.microsoft.com/office/drawing/2014/main" xmlns="" w="9525">
+                <a14:hiddenLine xmlns="" xmlns:a16="http://schemas.microsoft.com/office/drawing/2014/main" xmlns:p14="http://schemas.microsoft.com/office/powerpoint/2010/main" xmlns:a14="http://schemas.microsoft.com/office/drawing/2010/main" w="9525">
                   <a:solidFill>
                     <a:srgbClr val="000000"/>
                   </a:solidFill>
@@ -15202,7 +15203,7 @@
             </a:ln>
             <a:extLst>
               <a:ext uri="{91240B29-F687-4f45-9708-019B960494DF}">
-                <a14:hiddenLine xmlns:a14="http://schemas.microsoft.com/office/drawing/2010/main" xmlns:p14="http://schemas.microsoft.com/office/powerpoint/2010/main" xmlns:a16="http://schemas.microsoft.com/office/drawing/2014/main" xmlns="" w="9525">
+                <a14:hiddenLine xmlns="" xmlns:a16="http://schemas.microsoft.com/office/drawing/2014/main" xmlns:p14="http://schemas.microsoft.com/office/powerpoint/2010/main" xmlns:a14="http://schemas.microsoft.com/office/drawing/2010/main" w="9525">
                   <a:solidFill>
                     <a:srgbClr val="000000"/>
                   </a:solidFill>
@@ -15289,7 +15290,7 @@
             </a:ln>
             <a:extLst>
               <a:ext uri="{91240B29-F687-4f45-9708-019B960494DF}">
-                <a14:hiddenLine xmlns:a14="http://schemas.microsoft.com/office/drawing/2010/main" xmlns:p14="http://schemas.microsoft.com/office/powerpoint/2010/main" xmlns:a16="http://schemas.microsoft.com/office/drawing/2014/main" xmlns="" w="9525">
+                <a14:hiddenLine xmlns="" xmlns:a16="http://schemas.microsoft.com/office/drawing/2014/main" xmlns:p14="http://schemas.microsoft.com/office/powerpoint/2010/main" xmlns:a14="http://schemas.microsoft.com/office/drawing/2010/main" w="9525">
                   <a:solidFill>
                     <a:srgbClr val="000000"/>
                   </a:solidFill>
@@ -15401,7 +15402,7 @@
             </a:ln>
             <a:extLst>
               <a:ext uri="{91240B29-F687-4f45-9708-019B960494DF}">
-                <a14:hiddenLine xmlns:a14="http://schemas.microsoft.com/office/drawing/2010/main" xmlns:p14="http://schemas.microsoft.com/office/powerpoint/2010/main" xmlns:a16="http://schemas.microsoft.com/office/drawing/2014/main" xmlns="" w="9525">
+                <a14:hiddenLine xmlns="" xmlns:a16="http://schemas.microsoft.com/office/drawing/2014/main" xmlns:p14="http://schemas.microsoft.com/office/powerpoint/2010/main" xmlns:a14="http://schemas.microsoft.com/office/drawing/2010/main" w="9525">
                   <a:solidFill>
                     <a:srgbClr val="000000"/>
                   </a:solidFill>
@@ -15485,7 +15486,7 @@
             </a:ln>
             <a:extLst>
               <a:ext uri="{91240B29-F687-4f45-9708-019B960494DF}">
-                <a14:hiddenLine xmlns:a14="http://schemas.microsoft.com/office/drawing/2010/main" xmlns:p14="http://schemas.microsoft.com/office/powerpoint/2010/main" xmlns:a16="http://schemas.microsoft.com/office/drawing/2014/main" xmlns="" w="9525">
+                <a14:hiddenLine xmlns="" xmlns:a16="http://schemas.microsoft.com/office/drawing/2014/main" xmlns:p14="http://schemas.microsoft.com/office/powerpoint/2010/main" xmlns:a14="http://schemas.microsoft.com/office/drawing/2010/main" w="9525">
                   <a:solidFill>
                     <a:srgbClr val="000000"/>
                   </a:solidFill>
@@ -15597,7 +15598,7 @@
             </a:ln>
             <a:extLst>
               <a:ext uri="{91240B29-F687-4f45-9708-019B960494DF}">
-                <a14:hiddenLine xmlns:a14="http://schemas.microsoft.com/office/drawing/2010/main" xmlns:p14="http://schemas.microsoft.com/office/powerpoint/2010/main" xmlns:a16="http://schemas.microsoft.com/office/drawing/2014/main" xmlns="" w="9525">
+                <a14:hiddenLine xmlns="" xmlns:a16="http://schemas.microsoft.com/office/drawing/2014/main" xmlns:p14="http://schemas.microsoft.com/office/powerpoint/2010/main" xmlns:a14="http://schemas.microsoft.com/office/drawing/2010/main" w="9525">
                   <a:solidFill>
                     <a:srgbClr val="000000"/>
                   </a:solidFill>
@@ -15684,7 +15685,7 @@
             </a:ln>
             <a:extLst>
               <a:ext uri="{91240B29-F687-4f45-9708-019B960494DF}">
-                <a14:hiddenLine xmlns:a14="http://schemas.microsoft.com/office/drawing/2010/main" xmlns:p14="http://schemas.microsoft.com/office/powerpoint/2010/main" xmlns:a16="http://schemas.microsoft.com/office/drawing/2014/main" xmlns="" w="9525">
+                <a14:hiddenLine xmlns="" xmlns:a16="http://schemas.microsoft.com/office/drawing/2014/main" xmlns:p14="http://schemas.microsoft.com/office/powerpoint/2010/main" xmlns:a14="http://schemas.microsoft.com/office/drawing/2010/main" w="9525">
                   <a:solidFill>
                     <a:srgbClr val="000000"/>
                   </a:solidFill>
@@ -15768,7 +15769,7 @@
             </a:ln>
             <a:extLst>
               <a:ext uri="{91240B29-F687-4f45-9708-019B960494DF}">
-                <a14:hiddenLine xmlns:a14="http://schemas.microsoft.com/office/drawing/2010/main" xmlns:p14="http://schemas.microsoft.com/office/powerpoint/2010/main" xmlns:a16="http://schemas.microsoft.com/office/drawing/2014/main" xmlns="" w="9525">
+                <a14:hiddenLine xmlns="" xmlns:a16="http://schemas.microsoft.com/office/drawing/2014/main" xmlns:p14="http://schemas.microsoft.com/office/powerpoint/2010/main" xmlns:a14="http://schemas.microsoft.com/office/drawing/2010/main" w="9525">
                   <a:solidFill>
                     <a:srgbClr val="000000"/>
                   </a:solidFill>
@@ -15880,7 +15881,7 @@
             </a:ln>
             <a:extLst>
               <a:ext uri="{91240B29-F687-4f45-9708-019B960494DF}">
-                <a14:hiddenLine xmlns:a14="http://schemas.microsoft.com/office/drawing/2010/main" xmlns:p14="http://schemas.microsoft.com/office/powerpoint/2010/main" xmlns:a16="http://schemas.microsoft.com/office/drawing/2014/main" xmlns="" w="9525">
+                <a14:hiddenLine xmlns="" xmlns:a16="http://schemas.microsoft.com/office/drawing/2014/main" xmlns:p14="http://schemas.microsoft.com/office/powerpoint/2010/main" xmlns:a14="http://schemas.microsoft.com/office/drawing/2010/main" w="9525">
                   <a:solidFill>
                     <a:srgbClr val="000000"/>
                   </a:solidFill>
@@ -15992,7 +15993,7 @@
             </a:ln>
             <a:extLst>
               <a:ext uri="{91240B29-F687-4f45-9708-019B960494DF}">
-                <a14:hiddenLine xmlns:a14="http://schemas.microsoft.com/office/drawing/2010/main" xmlns:p14="http://schemas.microsoft.com/office/powerpoint/2010/main" xmlns:a16="http://schemas.microsoft.com/office/drawing/2014/main" xmlns="" w="9525">
+                <a14:hiddenLine xmlns="" xmlns:a16="http://schemas.microsoft.com/office/drawing/2014/main" xmlns:p14="http://schemas.microsoft.com/office/powerpoint/2010/main" xmlns:a14="http://schemas.microsoft.com/office/drawing/2010/main" w="9525">
                   <a:solidFill>
                     <a:srgbClr val="000000"/>
                   </a:solidFill>
@@ -16079,7 +16080,7 @@
             </a:ln>
             <a:extLst>
               <a:ext uri="{91240B29-F687-4f45-9708-019B960494DF}">
-                <a14:hiddenLine xmlns:a14="http://schemas.microsoft.com/office/drawing/2010/main" xmlns:p14="http://schemas.microsoft.com/office/powerpoint/2010/main" xmlns:a16="http://schemas.microsoft.com/office/drawing/2014/main" xmlns="" w="9525">
+                <a14:hiddenLine xmlns="" xmlns:a16="http://schemas.microsoft.com/office/drawing/2014/main" xmlns:p14="http://schemas.microsoft.com/office/powerpoint/2010/main" xmlns:a14="http://schemas.microsoft.com/office/drawing/2010/main" w="9525">
                   <a:solidFill>
                     <a:srgbClr val="000000"/>
                   </a:solidFill>
@@ -16221,7 +16222,7 @@
             </a:ln>
             <a:extLst>
               <a:ext uri="{91240B29-F687-4f45-9708-019B960494DF}">
-                <a14:hiddenLine xmlns:a14="http://schemas.microsoft.com/office/drawing/2010/main" xmlns:p14="http://schemas.microsoft.com/office/powerpoint/2010/main" xmlns:a16="http://schemas.microsoft.com/office/drawing/2014/main" xmlns="" w="9525">
+                <a14:hiddenLine xmlns="" xmlns:a16="http://schemas.microsoft.com/office/drawing/2014/main" xmlns:p14="http://schemas.microsoft.com/office/powerpoint/2010/main" xmlns:a14="http://schemas.microsoft.com/office/drawing/2010/main" w="9525">
                   <a:solidFill>
                     <a:srgbClr val="000000"/>
                   </a:solidFill>
@@ -17146,7 +17147,7 @@
             </a:ln>
             <a:extLst>
               <a:ext uri="{91240B29-F687-4f45-9708-019B960494DF}">
-                <a14:hiddenLine xmlns:a14="http://schemas.microsoft.com/office/drawing/2010/main" xmlns:p14="http://schemas.microsoft.com/office/powerpoint/2010/main" xmlns:a16="http://schemas.microsoft.com/office/drawing/2014/main" xmlns="" w="9525">
+                <a14:hiddenLine xmlns="" xmlns:a16="http://schemas.microsoft.com/office/drawing/2014/main" xmlns:p14="http://schemas.microsoft.com/office/powerpoint/2010/main" xmlns:a14="http://schemas.microsoft.com/office/drawing/2010/main" w="9525">
                   <a:solidFill>
                     <a:srgbClr val="000000"/>
                   </a:solidFill>
@@ -17258,7 +17259,7 @@
             </a:ln>
             <a:extLst>
               <a:ext uri="{91240B29-F687-4f45-9708-019B960494DF}">
-                <a14:hiddenLine xmlns:a14="http://schemas.microsoft.com/office/drawing/2010/main" xmlns:p14="http://schemas.microsoft.com/office/powerpoint/2010/main" xmlns:a16="http://schemas.microsoft.com/office/drawing/2014/main" xmlns="" w="9525">
+                <a14:hiddenLine xmlns="" xmlns:a16="http://schemas.microsoft.com/office/drawing/2014/main" xmlns:p14="http://schemas.microsoft.com/office/powerpoint/2010/main" xmlns:a14="http://schemas.microsoft.com/office/drawing/2010/main" w="9525">
                   <a:solidFill>
                     <a:srgbClr val="000000"/>
                   </a:solidFill>
@@ -17370,7 +17371,7 @@
             </a:ln>
             <a:extLst>
               <a:ext uri="{91240B29-F687-4f45-9708-019B960494DF}">
-                <a14:hiddenLine xmlns:a14="http://schemas.microsoft.com/office/drawing/2010/main" xmlns:p14="http://schemas.microsoft.com/office/powerpoint/2010/main" xmlns:a16="http://schemas.microsoft.com/office/drawing/2014/main" xmlns="" w="9525">
+                <a14:hiddenLine xmlns="" xmlns:a16="http://schemas.microsoft.com/office/drawing/2014/main" xmlns:p14="http://schemas.microsoft.com/office/powerpoint/2010/main" xmlns:a14="http://schemas.microsoft.com/office/drawing/2010/main" w="9525">
                   <a:solidFill>
                     <a:srgbClr val="000000"/>
                   </a:solidFill>
@@ -17454,7 +17455,7 @@
             </a:ln>
             <a:extLst>
               <a:ext uri="{91240B29-F687-4f45-9708-019B960494DF}">
-                <a14:hiddenLine xmlns:a14="http://schemas.microsoft.com/office/drawing/2010/main" xmlns:p14="http://schemas.microsoft.com/office/powerpoint/2010/main" xmlns:a16="http://schemas.microsoft.com/office/drawing/2014/main" xmlns="" w="9525">
+                <a14:hiddenLine xmlns="" xmlns:a16="http://schemas.microsoft.com/office/drawing/2014/main" xmlns:p14="http://schemas.microsoft.com/office/powerpoint/2010/main" xmlns:a14="http://schemas.microsoft.com/office/drawing/2010/main" w="9525">
                   <a:solidFill>
                     <a:srgbClr val="000000"/>
                   </a:solidFill>
@@ -17566,7 +17567,7 @@
             </a:ln>
             <a:extLst>
               <a:ext uri="{91240B29-F687-4f45-9708-019B960494DF}">
-                <a14:hiddenLine xmlns:a14="http://schemas.microsoft.com/office/drawing/2010/main" xmlns:p14="http://schemas.microsoft.com/office/powerpoint/2010/main" xmlns:a16="http://schemas.microsoft.com/office/drawing/2014/main" xmlns="" w="9525">
+                <a14:hiddenLine xmlns="" xmlns:a16="http://schemas.microsoft.com/office/drawing/2014/main" xmlns:p14="http://schemas.microsoft.com/office/powerpoint/2010/main" xmlns:a14="http://schemas.microsoft.com/office/drawing/2010/main" w="9525">
                   <a:solidFill>
                     <a:srgbClr val="000000"/>
                   </a:solidFill>
@@ -17650,7 +17651,7 @@
             </a:ln>
             <a:extLst>
               <a:ext uri="{91240B29-F687-4f45-9708-019B960494DF}">
-                <a14:hiddenLine xmlns:a14="http://schemas.microsoft.com/office/drawing/2010/main" xmlns:p14="http://schemas.microsoft.com/office/powerpoint/2010/main" xmlns:a16="http://schemas.microsoft.com/office/drawing/2014/main" xmlns="" w="9525">
+                <a14:hiddenLine xmlns="" xmlns:a16="http://schemas.microsoft.com/office/drawing/2014/main" xmlns:p14="http://schemas.microsoft.com/office/powerpoint/2010/main" xmlns:a14="http://schemas.microsoft.com/office/drawing/2010/main" w="9525">
                   <a:solidFill>
                     <a:srgbClr val="000000"/>
                   </a:solidFill>
@@ -17734,7 +17735,7 @@
             </a:ln>
             <a:extLst>
               <a:ext uri="{91240B29-F687-4f45-9708-019B960494DF}">
-                <a14:hiddenLine xmlns:a14="http://schemas.microsoft.com/office/drawing/2010/main" xmlns:p14="http://schemas.microsoft.com/office/powerpoint/2010/main" xmlns:a16="http://schemas.microsoft.com/office/drawing/2014/main" xmlns="" w="9525">
+                <a14:hiddenLine xmlns="" xmlns:a16="http://schemas.microsoft.com/office/drawing/2014/main" xmlns:p14="http://schemas.microsoft.com/office/powerpoint/2010/main" xmlns:a14="http://schemas.microsoft.com/office/drawing/2010/main" w="9525">
                   <a:solidFill>
                     <a:srgbClr val="000000"/>
                   </a:solidFill>
@@ -17846,7 +17847,7 @@
             </a:ln>
             <a:extLst>
               <a:ext uri="{91240B29-F687-4f45-9708-019B960494DF}">
-                <a14:hiddenLine xmlns:a14="http://schemas.microsoft.com/office/drawing/2010/main" xmlns:p14="http://schemas.microsoft.com/office/powerpoint/2010/main" xmlns:a16="http://schemas.microsoft.com/office/drawing/2014/main" xmlns="" w="9525">
+                <a14:hiddenLine xmlns="" xmlns:a16="http://schemas.microsoft.com/office/drawing/2014/main" xmlns:p14="http://schemas.microsoft.com/office/powerpoint/2010/main" xmlns:a14="http://schemas.microsoft.com/office/drawing/2010/main" w="9525">
                   <a:solidFill>
                     <a:srgbClr val="000000"/>
                   </a:solidFill>
@@ -17958,7 +17959,7 @@
             </a:ln>
             <a:extLst>
               <a:ext uri="{91240B29-F687-4f45-9708-019B960494DF}">
-                <a14:hiddenLine xmlns:a14="http://schemas.microsoft.com/office/drawing/2010/main" xmlns:p14="http://schemas.microsoft.com/office/powerpoint/2010/main" xmlns:a16="http://schemas.microsoft.com/office/drawing/2014/main" xmlns="" w="9525">
+                <a14:hiddenLine xmlns="" xmlns:a16="http://schemas.microsoft.com/office/drawing/2014/main" xmlns:p14="http://schemas.microsoft.com/office/powerpoint/2010/main" xmlns:a14="http://schemas.microsoft.com/office/drawing/2010/main" w="9525">
                   <a:solidFill>
                     <a:srgbClr val="000000"/>
                   </a:solidFill>
@@ -18042,7 +18043,7 @@
             </a:ln>
             <a:extLst>
               <a:ext uri="{91240B29-F687-4f45-9708-019B960494DF}">
-                <a14:hiddenLine xmlns:a14="http://schemas.microsoft.com/office/drawing/2010/main" xmlns:p14="http://schemas.microsoft.com/office/powerpoint/2010/main" xmlns:a16="http://schemas.microsoft.com/office/drawing/2014/main" xmlns="" w="9525">
+                <a14:hiddenLine xmlns="" xmlns:a16="http://schemas.microsoft.com/office/drawing/2014/main" xmlns:p14="http://schemas.microsoft.com/office/powerpoint/2010/main" xmlns:a14="http://schemas.microsoft.com/office/drawing/2010/main" w="9525">
                   <a:solidFill>
                     <a:srgbClr val="000000"/>
                   </a:solidFill>
@@ -18174,7 +18175,7 @@
             </a:ln>
             <a:extLst>
               <a:ext uri="{91240B29-F687-4f45-9708-019B960494DF}">
-                <a14:hiddenLine xmlns:a14="http://schemas.microsoft.com/office/drawing/2010/main" xmlns:p14="http://schemas.microsoft.com/office/powerpoint/2010/main" xmlns:a16="http://schemas.microsoft.com/office/drawing/2014/main" xmlns="" w="9525">
+                <a14:hiddenLine xmlns="" xmlns:a16="http://schemas.microsoft.com/office/drawing/2014/main" xmlns:p14="http://schemas.microsoft.com/office/powerpoint/2010/main" xmlns:a14="http://schemas.microsoft.com/office/drawing/2010/main" w="9525">
                   <a:solidFill>
                     <a:srgbClr val="000000"/>
                   </a:solidFill>
@@ -18302,7 +18303,7 @@
             </a:ln>
             <a:extLst>
               <a:ext uri="{91240B29-F687-4f45-9708-019B960494DF}">
-                <a14:hiddenLine xmlns:a14="http://schemas.microsoft.com/office/drawing/2010/main" xmlns:p14="http://schemas.microsoft.com/office/powerpoint/2010/main" xmlns:a16="http://schemas.microsoft.com/office/drawing/2014/main" xmlns="" w="9525">
+                <a14:hiddenLine xmlns="" xmlns:a16="http://schemas.microsoft.com/office/drawing/2014/main" xmlns:p14="http://schemas.microsoft.com/office/powerpoint/2010/main" xmlns:a14="http://schemas.microsoft.com/office/drawing/2010/main" w="9525">
                   <a:solidFill>
                     <a:srgbClr val="000000"/>
                   </a:solidFill>
@@ -18386,7 +18387,7 @@
             </a:ln>
             <a:extLst>
               <a:ext uri="{91240B29-F687-4f45-9708-019B960494DF}">
-                <a14:hiddenLine xmlns:a14="http://schemas.microsoft.com/office/drawing/2010/main" xmlns:p14="http://schemas.microsoft.com/office/powerpoint/2010/main" xmlns:a16="http://schemas.microsoft.com/office/drawing/2014/main" xmlns="" w="9525">
+                <a14:hiddenLine xmlns="" xmlns:a16="http://schemas.microsoft.com/office/drawing/2014/main" xmlns:p14="http://schemas.microsoft.com/office/powerpoint/2010/main" xmlns:a14="http://schemas.microsoft.com/office/drawing/2010/main" w="9525">
                   <a:solidFill>
                     <a:srgbClr val="000000"/>
                   </a:solidFill>
@@ -18470,7 +18471,7 @@
             </a:ln>
             <a:extLst>
               <a:ext uri="{91240B29-F687-4f45-9708-019B960494DF}">
-                <a14:hiddenLine xmlns:a14="http://schemas.microsoft.com/office/drawing/2010/main" xmlns:p14="http://schemas.microsoft.com/office/powerpoint/2010/main" xmlns:a16="http://schemas.microsoft.com/office/drawing/2014/main" xmlns="" w="9525">
+                <a14:hiddenLine xmlns="" xmlns:a16="http://schemas.microsoft.com/office/drawing/2014/main" xmlns:p14="http://schemas.microsoft.com/office/powerpoint/2010/main" xmlns:a14="http://schemas.microsoft.com/office/drawing/2010/main" w="9525">
                   <a:solidFill>
                     <a:srgbClr val="000000"/>
                   </a:solidFill>
@@ -18582,7 +18583,7 @@
             </a:ln>
             <a:extLst>
               <a:ext uri="{91240B29-F687-4f45-9708-019B960494DF}">
-                <a14:hiddenLine xmlns:a14="http://schemas.microsoft.com/office/drawing/2010/main" xmlns:p14="http://schemas.microsoft.com/office/powerpoint/2010/main" xmlns:a16="http://schemas.microsoft.com/office/drawing/2014/main" xmlns="" w="9525">
+                <a14:hiddenLine xmlns="" xmlns:a16="http://schemas.microsoft.com/office/drawing/2014/main" xmlns:p14="http://schemas.microsoft.com/office/powerpoint/2010/main" xmlns:a14="http://schemas.microsoft.com/office/drawing/2010/main" w="9525">
                   <a:solidFill>
                     <a:srgbClr val="000000"/>
                   </a:solidFill>
@@ -18638,7 +18639,7 @@
             </a:ln>
             <a:extLst>
               <a:ext uri="{91240B29-F687-4f45-9708-019B960494DF}">
-                <a14:hiddenLine xmlns:a14="http://schemas.microsoft.com/office/drawing/2010/main" xmlns:p14="http://schemas.microsoft.com/office/powerpoint/2010/main" xmlns:a16="http://schemas.microsoft.com/office/drawing/2014/main" xmlns="" w="9525">
+                <a14:hiddenLine xmlns="" xmlns:a16="http://schemas.microsoft.com/office/drawing/2014/main" xmlns:p14="http://schemas.microsoft.com/office/powerpoint/2010/main" xmlns:a14="http://schemas.microsoft.com/office/drawing/2010/main" w="9525">
                   <a:solidFill>
                     <a:srgbClr val="000000"/>
                   </a:solidFill>
@@ -18725,7 +18726,7 @@
             </a:ln>
             <a:extLst>
               <a:ext uri="{91240B29-F687-4f45-9708-019B960494DF}">
-                <a14:hiddenLine xmlns:a14="http://schemas.microsoft.com/office/drawing/2010/main" xmlns:p14="http://schemas.microsoft.com/office/powerpoint/2010/main" xmlns:a16="http://schemas.microsoft.com/office/drawing/2014/main" xmlns="" w="9525">
+                <a14:hiddenLine xmlns="" xmlns:a16="http://schemas.microsoft.com/office/drawing/2014/main" xmlns:p14="http://schemas.microsoft.com/office/powerpoint/2010/main" xmlns:a14="http://schemas.microsoft.com/office/drawing/2010/main" w="9525">
                   <a:solidFill>
                     <a:srgbClr val="000000"/>
                   </a:solidFill>
@@ -18837,7 +18838,7 @@
             </a:ln>
             <a:extLst>
               <a:ext uri="{91240B29-F687-4f45-9708-019B960494DF}">
-                <a14:hiddenLine xmlns:a14="http://schemas.microsoft.com/office/drawing/2010/main" xmlns:p14="http://schemas.microsoft.com/office/powerpoint/2010/main" xmlns:a16="http://schemas.microsoft.com/office/drawing/2014/main" xmlns="" w="9525">
+                <a14:hiddenLine xmlns="" xmlns:a16="http://schemas.microsoft.com/office/drawing/2014/main" xmlns:p14="http://schemas.microsoft.com/office/powerpoint/2010/main" xmlns:a14="http://schemas.microsoft.com/office/drawing/2010/main" w="9525">
                   <a:solidFill>
                     <a:srgbClr val="000000"/>
                   </a:solidFill>
@@ -18921,7 +18922,7 @@
             </a:ln>
             <a:extLst>
               <a:ext uri="{91240B29-F687-4f45-9708-019B960494DF}">
-                <a14:hiddenLine xmlns:a14="http://schemas.microsoft.com/office/drawing/2010/main" xmlns:p14="http://schemas.microsoft.com/office/powerpoint/2010/main" xmlns:a16="http://schemas.microsoft.com/office/drawing/2014/main" xmlns="" w="9525">
+                <a14:hiddenLine xmlns="" xmlns:a16="http://schemas.microsoft.com/office/drawing/2014/main" xmlns:p14="http://schemas.microsoft.com/office/powerpoint/2010/main" xmlns:a14="http://schemas.microsoft.com/office/drawing/2010/main" w="9525">
                   <a:solidFill>
                     <a:srgbClr val="000000"/>
                   </a:solidFill>
@@ -19033,7 +19034,7 @@
             </a:ln>
             <a:extLst>
               <a:ext uri="{91240B29-F687-4f45-9708-019B960494DF}">
-                <a14:hiddenLine xmlns:a14="http://schemas.microsoft.com/office/drawing/2010/main" xmlns:p14="http://schemas.microsoft.com/office/powerpoint/2010/main" xmlns:a16="http://schemas.microsoft.com/office/drawing/2014/main" xmlns="" w="9525">
+                <a14:hiddenLine xmlns="" xmlns:a16="http://schemas.microsoft.com/office/drawing/2014/main" xmlns:p14="http://schemas.microsoft.com/office/powerpoint/2010/main" xmlns:a14="http://schemas.microsoft.com/office/drawing/2010/main" w="9525">
                   <a:solidFill>
                     <a:srgbClr val="000000"/>
                   </a:solidFill>
@@ -19120,7 +19121,7 @@
             </a:ln>
             <a:extLst>
               <a:ext uri="{91240B29-F687-4f45-9708-019B960494DF}">
-                <a14:hiddenLine xmlns:a14="http://schemas.microsoft.com/office/drawing/2010/main" xmlns:p14="http://schemas.microsoft.com/office/powerpoint/2010/main" xmlns:a16="http://schemas.microsoft.com/office/drawing/2014/main" xmlns="" w="9525">
+                <a14:hiddenLine xmlns="" xmlns:a16="http://schemas.microsoft.com/office/drawing/2014/main" xmlns:p14="http://schemas.microsoft.com/office/powerpoint/2010/main" xmlns:a14="http://schemas.microsoft.com/office/drawing/2010/main" w="9525">
                   <a:solidFill>
                     <a:srgbClr val="000000"/>
                   </a:solidFill>
@@ -19204,7 +19205,7 @@
             </a:ln>
             <a:extLst>
               <a:ext uri="{91240B29-F687-4f45-9708-019B960494DF}">
-                <a14:hiddenLine xmlns:a14="http://schemas.microsoft.com/office/drawing/2010/main" xmlns:p14="http://schemas.microsoft.com/office/powerpoint/2010/main" xmlns:a16="http://schemas.microsoft.com/office/drawing/2014/main" xmlns="" w="9525">
+                <a14:hiddenLine xmlns="" xmlns:a16="http://schemas.microsoft.com/office/drawing/2014/main" xmlns:p14="http://schemas.microsoft.com/office/powerpoint/2010/main" xmlns:a14="http://schemas.microsoft.com/office/drawing/2010/main" w="9525">
                   <a:solidFill>
                     <a:srgbClr val="000000"/>
                   </a:solidFill>
@@ -19316,7 +19317,7 @@
             </a:ln>
             <a:extLst>
               <a:ext uri="{91240B29-F687-4f45-9708-019B960494DF}">
-                <a14:hiddenLine xmlns:a14="http://schemas.microsoft.com/office/drawing/2010/main" xmlns:p14="http://schemas.microsoft.com/office/powerpoint/2010/main" xmlns:a16="http://schemas.microsoft.com/office/drawing/2014/main" xmlns="" w="9525">
+                <a14:hiddenLine xmlns="" xmlns:a16="http://schemas.microsoft.com/office/drawing/2014/main" xmlns:p14="http://schemas.microsoft.com/office/powerpoint/2010/main" xmlns:a14="http://schemas.microsoft.com/office/drawing/2010/main" w="9525">
                   <a:solidFill>
                     <a:srgbClr val="000000"/>
                   </a:solidFill>
@@ -19428,7 +19429,7 @@
             </a:ln>
             <a:extLst>
               <a:ext uri="{91240B29-F687-4f45-9708-019B960494DF}">
-                <a14:hiddenLine xmlns:a14="http://schemas.microsoft.com/office/drawing/2010/main" xmlns:p14="http://schemas.microsoft.com/office/powerpoint/2010/main" xmlns:a16="http://schemas.microsoft.com/office/drawing/2014/main" xmlns="" w="9525">
+                <a14:hiddenLine xmlns="" xmlns:a16="http://schemas.microsoft.com/office/drawing/2014/main" xmlns:p14="http://schemas.microsoft.com/office/powerpoint/2010/main" xmlns:a14="http://schemas.microsoft.com/office/drawing/2010/main" w="9525">
                   <a:solidFill>
                     <a:srgbClr val="000000"/>
                   </a:solidFill>
@@ -19515,7 +19516,7 @@
             </a:ln>
             <a:extLst>
               <a:ext uri="{91240B29-F687-4f45-9708-019B960494DF}">
-                <a14:hiddenLine xmlns:a14="http://schemas.microsoft.com/office/drawing/2010/main" xmlns:p14="http://schemas.microsoft.com/office/powerpoint/2010/main" xmlns:a16="http://schemas.microsoft.com/office/drawing/2014/main" xmlns="" w="9525">
+                <a14:hiddenLine xmlns="" xmlns:a16="http://schemas.microsoft.com/office/drawing/2014/main" xmlns:p14="http://schemas.microsoft.com/office/powerpoint/2010/main" xmlns:a14="http://schemas.microsoft.com/office/drawing/2010/main" w="9525">
                   <a:solidFill>
                     <a:srgbClr val="000000"/>
                   </a:solidFill>
@@ -19657,7 +19658,7 @@
             </a:ln>
             <a:extLst>
               <a:ext uri="{91240B29-F687-4f45-9708-019B960494DF}">
-                <a14:hiddenLine xmlns:a14="http://schemas.microsoft.com/office/drawing/2010/main" xmlns:p14="http://schemas.microsoft.com/office/powerpoint/2010/main" xmlns:a16="http://schemas.microsoft.com/office/drawing/2014/main" xmlns="" w="9525">
+                <a14:hiddenLine xmlns="" xmlns:a16="http://schemas.microsoft.com/office/drawing/2014/main" xmlns:p14="http://schemas.microsoft.com/office/powerpoint/2010/main" xmlns:a14="http://schemas.microsoft.com/office/drawing/2010/main" w="9525">
                   <a:solidFill>
                     <a:srgbClr val="000000"/>
                   </a:solidFill>
@@ -19905,6 +19906,106 @@
 </file>
 
 <file path=ppt/slides/slide20.xml><?xml version="1.0" encoding="utf-8"?>
+<p:sld xmlns:a="http://schemas.openxmlformats.org/drawingml/2006/main" xmlns:r="http://schemas.openxmlformats.org/officeDocument/2006/relationships" xmlns:p="http://schemas.openxmlformats.org/presentationml/2006/main">
+  <p:cSld>
+    <p:spTree>
+      <p:nvGrpSpPr>
+        <p:cNvPr id="1" name="">
+          <a:extLst>
+            <a:ext uri="{FF2B5EF4-FFF2-40B4-BE49-F238E27FC236}">
+              <a16:creationId xmlns:a16="http://schemas.microsoft.com/office/drawing/2014/main" id="{C0BB67F8-FE87-1C1B-2639-42EFD909B6D8}"/>
+            </a:ext>
+          </a:extLst>
+        </p:cNvPr>
+        <p:cNvGrpSpPr/>
+        <p:nvPr/>
+      </p:nvGrpSpPr>
+      <p:grpSpPr>
+        <a:xfrm>
+          <a:off x="0" y="0"/>
+          <a:ext cx="0" cy="0"/>
+          <a:chOff x="0" y="0"/>
+          <a:chExt cx="0" cy="0"/>
+        </a:xfrm>
+      </p:grpSpPr>
+      <p:sp>
+        <p:nvSpPr>
+          <p:cNvPr id="2" name="Título 1">
+            <a:extLst>
+              <a:ext uri="{FF2B5EF4-FFF2-40B4-BE49-F238E27FC236}">
+                <a16:creationId xmlns:a16="http://schemas.microsoft.com/office/drawing/2014/main" id="{AA946CB4-6FE7-8009-73EB-C4CCE345AAEE}"/>
+              </a:ext>
+            </a:extLst>
+          </p:cNvPr>
+          <p:cNvSpPr>
+            <a:spLocks noGrp="1"/>
+          </p:cNvSpPr>
+          <p:nvPr>
+            <p:ph type="title"/>
+          </p:nvPr>
+        </p:nvSpPr>
+        <p:spPr/>
+        <p:txBody>
+          <a:bodyPr/>
+          <a:lstStyle/>
+          <a:p>
+            <a:r>
+              <a:rPr lang="pt-PT" dirty="0"/>
+              <a:t>Trabalhos Futuros</a:t>
+            </a:r>
+          </a:p>
+        </p:txBody>
+      </p:sp>
+      <p:sp>
+        <p:nvSpPr>
+          <p:cNvPr id="3" name="Espaço Reservado para Conteúdo 2">
+            <a:extLst>
+              <a:ext uri="{FF2B5EF4-FFF2-40B4-BE49-F238E27FC236}">
+                <a16:creationId xmlns:a16="http://schemas.microsoft.com/office/drawing/2014/main" id="{F729D733-DD6F-3755-00AC-6376BEDDCC16}"/>
+              </a:ext>
+            </a:extLst>
+          </p:cNvPr>
+          <p:cNvSpPr>
+            <a:spLocks noGrp="1"/>
+          </p:cNvSpPr>
+          <p:nvPr>
+            <p:ph idx="1"/>
+          </p:nvPr>
+        </p:nvSpPr>
+        <p:spPr/>
+        <p:txBody>
+          <a:bodyPr>
+            <a:normAutofit/>
+          </a:bodyPr>
+          <a:lstStyle/>
+          <a:p>
+            <a:r>
+              <a:rPr lang="pt-PT" dirty="0"/>
+              <a:t>Nossa memória atual pode crescer com novos termos. Uma WiSARD exige uma entrada de dimensão fixa; </a:t>
+            </a:r>
+          </a:p>
+          <a:p>
+            <a:r>
+              <a:rPr lang="pt-PT" dirty="0"/>
+              <a:t>por isso, como trabalho futuro, vamos avaliar congelamento de vocabulário ou hashing de características para tornar essa integração incremental e experimentalmente comparável.</a:t>
+            </a:r>
+          </a:p>
+        </p:txBody>
+      </p:sp>
+    </p:spTree>
+    <p:extLst>
+      <p:ext uri="{BB962C8B-B14F-4D97-AF65-F5344CB8AC3E}">
+        <p14:creationId xmlns:p14="http://schemas.microsoft.com/office/powerpoint/2010/main" val="2651206013"/>
+      </p:ext>
+    </p:extLst>
+  </p:cSld>
+  <p:clrMapOvr>
+    <a:masterClrMapping/>
+  </p:clrMapOvr>
+</p:sld>
+</file>
+
+<file path=ppt/slides/slide21.xml><?xml version="1.0" encoding="utf-8"?>
 <p:sld xmlns:a="http://schemas.openxmlformats.org/drawingml/2006/main" xmlns:r="http://schemas.openxmlformats.org/officeDocument/2006/relationships" xmlns:p="http://schemas.openxmlformats.org/presentationml/2006/main">
   <p:cSld>
     <p:spTree>

</xml_diff>